<commit_message>
Add timeline and team slide; credit the host platform
New slide 14: a dated timeline down the left, two equally-weighted role cards
on the right, and the repo link with the scored commit SHA along the bottom.

The split is drawn along the seam the project actually had -- documents to
database on one side, question to number on the other. That division is what
gives the 155/155 reconciliation its force: the second extraction was written
by the person who did not write the first, over different documents, with no
shared parser.

Names ship as [ NAME 1 ] / [ NAME 2 ] placeholders rather than guesses; the
speaker note flags filling them in before presenting.

Also adds the JAW 2026 / GikaGraph host credit to the title and closing slides,
as text only -- no reproduction of their branding.
</commit_message>
<xml_diff>
--- a/presentation/JAW2026-winners-presentation.pptx
+++ b/presentation/JAW2026-winners-presentation.pptx
@@ -20,9 +20,10 @@
     <p:sldId id="268" r:id="rId14"/>
     <p:sldId id="269" r:id="rId15"/>
     <p:sldId id="270" r:id="rId16"/>
+    <p:sldId id="271" r:id="rId17"/>
   </p:sldIdLst>
   <p:notesMasterIdLst>
-    <p:notesMasterId r:id="rId17"/>
+    <p:notesMasterId r:id="rId18"/>
   </p:notesMasterIdLst>
   <p:sldSz cx="12192000" cy="6858000"/>
   <p:notesSz cx="6858000" cy="12192000"/>
@@ -1319,11 +1320,11 @@
           <a:p>
             <a:r>
               <a:rPr lang="en-US" dirty="0"/>
-              <a:t>90 seconds. This is the takeaway slide — the one the audience should leave with.
-One: separate classification from computation. Let the model decide what to compute and never let it compute. Under any error-proportional metric this is not a stylistic choice, it is the difference between a mediocre score and a perfect one.
-Two: corroborate the data layer before you trust any answer. Extracting the same facts twice by different routes cost us a day and bought us the deduction that every remaining error had to be in the query layer. That focused the entire endgame.
-Three: hunt for invariants that need no answer key. Ours found three silent wrong answers with zero gold data.
-Four: treat the scorer as an instrument. If you get a number back with real precision, you can do arithmetic on it and locate a fault analytically instead of guessing.</a:t>
+              <a:t>60 seconds. Fill in both names before presenting — the deck ships with placeholders.
+Five days end to end, and the split was clean: one of us owned everything from the documents to the database, the other owned everything from the question to the number.
+That division is not just organisational — it is why the reconciliation on slide 6 is worth anything. The second extraction was written by the person who did NOT write the first one, using a different set of documents and no shared parser. 155 out of 155 agreeing means something precisely because the two routes had nothing in common.
+On the timeline, note the two amber points. Both fell on the same afternoon, and between them they account for the move from 73 to 100. The first was an architectural decision; the second was measurement discipline. Neither was extra extraction work — by that stage the data was already right.
+The repo link is live and includes the full commit history, so the scored commit can be verified against the code that produced it.</a:t>
             </a:r>
             <a:endParaRPr lang="en-US" dirty="0"/>
           </a:p>
@@ -1411,6 +1412,98 @@
           <a:p>
             <a:r>
               <a:rPr lang="en-US" dirty="0"/>
+              <a:t>90 seconds. This is the takeaway slide — the one the audience should leave with.
+One: separate classification from computation. Let the model decide what to compute and never let it compute. Under any error-proportional metric this is not a stylistic choice, it is the difference between a mediocre score and a perfect one.
+Two: corroborate the data layer before you trust any answer. Extracting the same facts twice by different routes cost us a day and bought us the deduction that every remaining error had to be in the query layer. That focused the entire endgame.
+Three: hunt for invariants that need no answer key. Ours found three silent wrong answers with zero gold data.
+Four: treat the scorer as an instrument. If you get a number back with real precision, you can do arithmetic on it and locate a fault analytically instead of guessing.</a:t>
+            </a:r>
+            <a:endParaRPr lang="en-US" dirty="0"/>
+          </a:p>
+        </p:txBody>
+      </p:sp>
+      <p:sp>
+        <p:nvSpPr>
+          <p:cNvPr id="4" name="Slide Number Placeholder 3"/>
+          <p:cNvSpPr>
+            <a:spLocks noGrp="1"/>
+          </p:cNvSpPr>
+          <p:nvPr>
+            <p:ph type="sldNum" sz="quarter" idx="10"/>
+          </p:nvPr>
+        </p:nvSpPr>
+        <p:spPr/>
+        <p:txBody>
+          <a:bodyPr/>
+          <a:lstStyle/>
+          <a:p>
+            <a:fld id="{F7021451-1387-4CA6-816F-3879F97B5CBC}" type="slidenum">
+              <a:rPr lang="en-US"/>
+              <a:t>15</a:t>
+            </a:fld>
+            <a:endParaRPr lang="en-US"/>
+          </a:p>
+        </p:txBody>
+      </p:sp>
+    </p:spTree>
+    <p:extLst>
+      <p:ext uri="{BB962C8B-B14F-4D97-AF65-F5344CB8AC3E}">
+        <p14:creationId xmlns:p14="http://schemas.microsoft.com/office/powerpoint/2010/main" val="1024086991"/>
+      </p:ext>
+    </p:extLst>
+  </p:cSld>
+  <p:clrMapOvr>
+    <a:masterClrMapping/>
+  </p:clrMapOvr>
+</p:notes>
+</file>
+
+<file path=ppt/notesSlides/notesSlide16.xml><?xml version="1.0" encoding="utf-8"?>
+<p:notes xmlns:a="http://schemas.openxmlformats.org/drawingml/2006/main" xmlns:r="http://schemas.openxmlformats.org/officeDocument/2006/relationships" xmlns:p="http://schemas.openxmlformats.org/presentationml/2006/main">
+  <p:cSld>
+    <p:spTree>
+      <p:nvGrpSpPr>
+        <p:cNvPr id="1" name=""/>
+        <p:cNvGrpSpPr/>
+        <p:nvPr/>
+      </p:nvGrpSpPr>
+      <p:grpSpPr>
+        <a:xfrm>
+          <a:off x="0" y="0"/>
+          <a:ext cx="0" cy="0"/>
+          <a:chOff x="0" y="0"/>
+          <a:chExt cx="0" cy="0"/>
+        </a:xfrm>
+      </p:grpSpPr>
+      <p:sp>
+        <p:nvSpPr>
+          <p:cNvPr id="2" name="Slide Image Placeholder 1"/>
+          <p:cNvSpPr>
+            <a:spLocks noGrp="1" noRot="1" noChangeAspect="1"/>
+          </p:cNvSpPr>
+          <p:nvPr>
+            <p:ph type="sldImg"/>
+          </p:nvPr>
+        </p:nvSpPr>
+        <p:spPr/>
+      </p:sp>
+      <p:sp>
+        <p:nvSpPr>
+          <p:cNvPr id="3" name="Notes Placeholder 2"/>
+          <p:cNvSpPr>
+            <a:spLocks noGrp="1"/>
+          </p:cNvSpPr>
+          <p:nvPr>
+            <p:ph type="body" idx="1"/>
+          </p:nvPr>
+        </p:nvSpPr>
+        <p:spPr/>
+        <p:txBody>
+          <a:bodyPr/>
+          <a:lstStyle/>
+          <a:p>
+            <a:r>
+              <a:rPr lang="en-US" dirty="0"/>
               <a:t>Close in 30 seconds, then open for questions.
 100.000. Every one of 333 questions exact, over 687 documents and a database that was never given to us.
 And the line worth ending on: there is no language model in the answer path at all. Every number in that submission was computed in Python from integers parsed exactly out of the documents. The intelligence went into deciding what to compute — the computing itself stayed where it can be checked.
@@ -1445,7 +1538,7 @@
           <a:p>
             <a:fld id="{F7021451-1387-4CA6-816F-3879F97B5CBC}" type="slidenum">
               <a:rPr lang="en-US"/>
-              <a:t>15</a:t>
+              <a:t>16</a:t>
             </a:fld>
             <a:endParaRPr lang="en-US"/>
           </a:p>
@@ -2859,7 +2952,7 @@
         </p:nvSpPr>
         <p:spPr>
           <a:xfrm>
-            <a:off x="566928" y="5806440"/>
+            <a:off x="566928" y="5577840"/>
             <a:ext cx="10058400" cy="320040"/>
           </a:xfrm>
           <a:prstGeom prst="rect">
@@ -2887,6 +2980,45 @@
               <a:t>Started at 49.822 · seven scored submissions later, 100.000</a:t>
             </a:r>
             <a:endParaRPr lang="en-US" sz="1300" dirty="0"/>
+          </a:p>
+        </p:txBody>
+      </p:sp>
+      <p:sp>
+        <p:nvSpPr>
+          <p:cNvPr id="11" name="Text 9"/>
+          <p:cNvSpPr/>
+          <p:nvPr/>
+        </p:nvSpPr>
+        <p:spPr>
+          <a:xfrm>
+            <a:off x="566928" y="6053328"/>
+            <a:ext cx="7772400" cy="274320"/>
+          </a:xfrm>
+          <a:prstGeom prst="rect">
+            <a:avLst/>
+          </a:prstGeom>
+          <a:noFill/>
+          <a:ln/>
+        </p:spPr>
+        <p:txBody>
+          <a:bodyPr wrap="square" lIns="0" tIns="0" rIns="0" bIns="0" rtlCol="0" anchor="ctr"/>
+          <a:lstStyle/>
+          <a:p>
+            <a:pPr indent="0" marL="0">
+              <a:buNone/>
+            </a:pPr>
+            <a:r>
+              <a:rPr lang="en-US" sz="1100" dirty="0">
+                <a:solidFill>
+                  <a:srgbClr val="2A5C7A"/>
+                </a:solidFill>
+                <a:latin typeface="Calibri" pitchFamily="34" charset="0"/>
+                <a:ea typeface="Calibri" pitchFamily="34" charset="-122"/>
+                <a:cs typeface="Calibri" pitchFamily="34" charset="-120"/>
+              </a:rPr>
+              <a:t>JAW 2026 · hosted on GikaGraph · jaw.hackathon.gikagraph.ai</a:t>
+            </a:r>
+            <a:endParaRPr lang="en-US" sz="1100" dirty="0"/>
           </a:p>
         </p:txBody>
       </p:sp>
@@ -6907,7 +7039,7 @@
     <p:bg>
       <p:bgPr>
         <a:solidFill>
-          <a:srgbClr val="0F1E2E"/>
+          <a:srgbClr val="FFFFFF"/>
         </a:solidFill>
       </p:bgPr>
     </p:bg>
@@ -6933,47 +7065,488 @@
         </p:nvSpPr>
         <p:spPr>
           <a:xfrm>
-            <a:off x="566928" y="685800"/>
-            <a:ext cx="7315200" cy="640080"/>
-          </a:xfrm>
-          <a:prstGeom prst="rect">
-            <a:avLst/>
-          </a:prstGeom>
-          <a:noFill/>
-          <a:ln/>
-        </p:spPr>
-        <p:txBody>
-          <a:bodyPr wrap="square" lIns="0" tIns="0" rIns="0" bIns="0" rtlCol="0" anchor="ctr"/>
-          <a:lstStyle/>
-          <a:p>
-            <a:pPr indent="0" marL="0">
-              <a:buNone/>
-            </a:pPr>
-            <a:r>
-              <a:rPr lang="en-US" sz="3400" b="1" dirty="0">
-                <a:solidFill>
-                  <a:srgbClr val="FFFFFF"/>
+            <a:off x="566928" y="384048"/>
+            <a:ext cx="7315200" cy="274320"/>
+          </a:xfrm>
+          <a:prstGeom prst="rect">
+            <a:avLst/>
+          </a:prstGeom>
+          <a:noFill/>
+          <a:ln/>
+        </p:spPr>
+        <p:txBody>
+          <a:bodyPr wrap="square" lIns="0" tIns="0" rIns="0" bIns="0" rtlCol="0" anchor="ctr"/>
+          <a:lstStyle/>
+          <a:p>
+            <a:pPr indent="0" marL="0">
+              <a:buNone/>
+            </a:pPr>
+            <a:r>
+              <a:rPr lang="en-US" sz="1200" b="1" spc="200" kern="0" dirty="0">
+                <a:solidFill>
+                  <a:srgbClr val="F2A104"/>
+                </a:solidFill>
+                <a:latin typeface="Calibri" pitchFamily="34" charset="0"/>
+                <a:ea typeface="Calibri" pitchFamily="34" charset="-122"/>
+                <a:cs typeface="Calibri" pitchFamily="34" charset="-120"/>
+              </a:rPr>
+              <a:t>TIMELINE AND TEAM</a:t>
+            </a:r>
+            <a:endParaRPr lang="en-US" sz="1200" dirty="0"/>
+          </a:p>
+        </p:txBody>
+      </p:sp>
+      <p:sp>
+        <p:nvSpPr>
+          <p:cNvPr id="3" name="Text 1"/>
+          <p:cNvSpPr/>
+          <p:nvPr/>
+        </p:nvSpPr>
+        <p:spPr>
+          <a:xfrm>
+            <a:off x="566928" y="676656"/>
+            <a:ext cx="11057839" cy="685800"/>
+          </a:xfrm>
+          <a:prstGeom prst="rect">
+            <a:avLst/>
+          </a:prstGeom>
+          <a:noFill/>
+          <a:ln/>
+        </p:spPr>
+        <p:txBody>
+          <a:bodyPr wrap="square" lIns="0" tIns="0" rIns="0" bIns="0" rtlCol="0" anchor="ctr"/>
+          <a:lstStyle/>
+          <a:p>
+            <a:pPr indent="0" marL="0">
+              <a:buNone/>
+            </a:pPr>
+            <a:r>
+              <a:rPr lang="en-US" sz="3200" b="1" dirty="0">
+                <a:solidFill>
+                  <a:srgbClr val="0F1E2E"/>
                 </a:solidFill>
                 <a:latin typeface="Cambria" pitchFamily="34" charset="0"/>
                 <a:ea typeface="Cambria" pitchFamily="34" charset="-122"/>
                 <a:cs typeface="Cambria" pitchFamily="34" charset="-120"/>
               </a:rPr>
-              <a:t>What generalises</a:t>
-            </a:r>
-            <a:endParaRPr lang="en-US" sz="3400" dirty="0"/>
-          </a:p>
-        </p:txBody>
-      </p:sp>
-      <p:sp>
-        <p:nvSpPr>
-          <p:cNvPr id="3" name="Shape 1"/>
-          <p:cNvSpPr/>
-          <p:nvPr/>
-        </p:nvSpPr>
-        <p:spPr>
-          <a:xfrm>
-            <a:off x="566928" y="1600200"/>
-            <a:ext cx="402336" cy="402336"/>
+              <a:t>Five days, two people</a:t>
+            </a:r>
+            <a:endParaRPr lang="en-US" sz="3200" dirty="0"/>
+          </a:p>
+        </p:txBody>
+      </p:sp>
+      <p:sp>
+        <p:nvSpPr>
+          <p:cNvPr id="4" name="Text 2"/>
+          <p:cNvSpPr/>
+          <p:nvPr/>
+        </p:nvSpPr>
+        <p:spPr>
+          <a:xfrm>
+            <a:off x="566928" y="1783080"/>
+            <a:ext cx="4754880" cy="256032"/>
+          </a:xfrm>
+          <a:prstGeom prst="rect">
+            <a:avLst/>
+          </a:prstGeom>
+          <a:noFill/>
+          <a:ln/>
+        </p:spPr>
+        <p:txBody>
+          <a:bodyPr wrap="square" lIns="0" tIns="0" rIns="0" bIns="0" rtlCol="0" anchor="ctr"/>
+          <a:lstStyle/>
+          <a:p>
+            <a:pPr indent="0" marL="0">
+              <a:buNone/>
+            </a:pPr>
+            <a:r>
+              <a:rPr lang="en-US" sz="1100" b="1" spc="150" kern="0" dirty="0">
+                <a:solidFill>
+                  <a:srgbClr val="F2A104"/>
+                </a:solidFill>
+                <a:latin typeface="Calibri" pitchFamily="34" charset="0"/>
+                <a:ea typeface="Calibri" pitchFamily="34" charset="-122"/>
+                <a:cs typeface="Calibri" pitchFamily="34" charset="-120"/>
+              </a:rPr>
+              <a:t>TIMELINE</a:t>
+            </a:r>
+            <a:endParaRPr lang="en-US" sz="1100" dirty="0"/>
+          </a:p>
+        </p:txBody>
+      </p:sp>
+      <p:sp>
+        <p:nvSpPr>
+          <p:cNvPr id="5" name="Shape 3"/>
+          <p:cNvSpPr/>
+          <p:nvPr/>
+        </p:nvSpPr>
+        <p:spPr>
+          <a:xfrm>
+            <a:off x="585216" y="2212848"/>
+            <a:ext cx="182880" cy="182880"/>
+          </a:xfrm>
+          <a:prstGeom prst="ellipse">
+            <a:avLst/>
+          </a:prstGeom>
+          <a:solidFill>
+            <a:srgbClr val="2A5C7A"/>
+          </a:solidFill>
+          <a:ln/>
+        </p:spPr>
+      </p:sp>
+      <p:sp>
+        <p:nvSpPr>
+          <p:cNvPr id="6" name="Shape 4"/>
+          <p:cNvSpPr/>
+          <p:nvPr/>
+        </p:nvSpPr>
+        <p:spPr>
+          <a:xfrm>
+            <a:off x="667512" y="2395728"/>
+            <a:ext cx="18288" cy="365760"/>
+          </a:xfrm>
+          <a:prstGeom prst="rect">
+            <a:avLst/>
+          </a:prstGeom>
+          <a:solidFill>
+            <a:srgbClr val="D5DEE5"/>
+          </a:solidFill>
+          <a:ln/>
+        </p:spPr>
+      </p:sp>
+      <p:sp>
+        <p:nvSpPr>
+          <p:cNvPr id="7" name="Text 5"/>
+          <p:cNvSpPr/>
+          <p:nvPr/>
+        </p:nvSpPr>
+        <p:spPr>
+          <a:xfrm>
+            <a:off x="932688" y="2148840"/>
+            <a:ext cx="1234440" cy="274320"/>
+          </a:xfrm>
+          <a:prstGeom prst="rect">
+            <a:avLst/>
+          </a:prstGeom>
+          <a:noFill/>
+          <a:ln/>
+        </p:spPr>
+        <p:txBody>
+          <a:bodyPr wrap="square" lIns="0" tIns="0" rIns="0" bIns="0" rtlCol="0" anchor="ctr"/>
+          <a:lstStyle/>
+          <a:p>
+            <a:pPr indent="0" marL="0">
+              <a:buNone/>
+            </a:pPr>
+            <a:r>
+              <a:rPr lang="en-US" sz="1200" b="1" dirty="0">
+                <a:solidFill>
+                  <a:srgbClr val="0F1E2E"/>
+                </a:solidFill>
+                <a:latin typeface="Calibri" pitchFamily="34" charset="0"/>
+                <a:ea typeface="Calibri" pitchFamily="34" charset="-122"/>
+                <a:cs typeface="Calibri" pitchFamily="34" charset="-120"/>
+              </a:rPr>
+              <a:t>9 Aug</a:t>
+            </a:r>
+            <a:endParaRPr lang="en-US" sz="1200" dirty="0"/>
+          </a:p>
+        </p:txBody>
+      </p:sp>
+      <p:sp>
+        <p:nvSpPr>
+          <p:cNvPr id="8" name="Text 6"/>
+          <p:cNvSpPr/>
+          <p:nvPr/>
+        </p:nvSpPr>
+        <p:spPr>
+          <a:xfrm>
+            <a:off x="2212848" y="2148840"/>
+            <a:ext cx="3291840" cy="502920"/>
+          </a:xfrm>
+          <a:prstGeom prst="rect">
+            <a:avLst/>
+          </a:prstGeom>
+          <a:noFill/>
+          <a:ln/>
+        </p:spPr>
+        <p:txBody>
+          <a:bodyPr wrap="square" lIns="0" tIns="0" rIns="0" bIns="0" rtlCol="0" anchor="ctr"/>
+          <a:lstStyle/>
+          <a:p>
+            <a:pPr indent="0" marL="0">
+              <a:lnSpc>
+                <a:spcPct val="105000"/>
+              </a:lnSpc>
+              <a:buNone/>
+            </a:pPr>
+            <a:r>
+              <a:rPr lang="en-US" sz="1150" dirty="0">
+                <a:solidFill>
+                  <a:srgbClr val="5A6B7A"/>
+                </a:solidFill>
+                <a:latin typeface="Calibri" pitchFamily="34" charset="0"/>
+                <a:ea typeface="Calibri" pitchFamily="34" charset="-122"/>
+                <a:cs typeface="Calibri" pitchFamily="34" charset="-120"/>
+              </a:rPr>
+              <a:t>Extraction built. 25/25 on the published samples, end to end.</a:t>
+            </a:r>
+            <a:endParaRPr lang="en-US" sz="1150" dirty="0"/>
+          </a:p>
+        </p:txBody>
+      </p:sp>
+      <p:sp>
+        <p:nvSpPr>
+          <p:cNvPr id="9" name="Shape 7"/>
+          <p:cNvSpPr/>
+          <p:nvPr/>
+        </p:nvSpPr>
+        <p:spPr>
+          <a:xfrm>
+            <a:off x="585216" y="2761488"/>
+            <a:ext cx="182880" cy="182880"/>
+          </a:xfrm>
+          <a:prstGeom prst="ellipse">
+            <a:avLst/>
+          </a:prstGeom>
+          <a:solidFill>
+            <a:srgbClr val="2A5C7A"/>
+          </a:solidFill>
+          <a:ln/>
+        </p:spPr>
+      </p:sp>
+      <p:sp>
+        <p:nvSpPr>
+          <p:cNvPr id="10" name="Shape 8"/>
+          <p:cNvSpPr/>
+          <p:nvPr/>
+        </p:nvSpPr>
+        <p:spPr>
+          <a:xfrm>
+            <a:off x="667512" y="2944368"/>
+            <a:ext cx="18288" cy="365760"/>
+          </a:xfrm>
+          <a:prstGeom prst="rect">
+            <a:avLst/>
+          </a:prstGeom>
+          <a:solidFill>
+            <a:srgbClr val="D5DEE5"/>
+          </a:solidFill>
+          <a:ln/>
+        </p:spPr>
+      </p:sp>
+      <p:sp>
+        <p:nvSpPr>
+          <p:cNvPr id="11" name="Text 9"/>
+          <p:cNvSpPr/>
+          <p:nvPr/>
+        </p:nvSpPr>
+        <p:spPr>
+          <a:xfrm>
+            <a:off x="932688" y="2697480"/>
+            <a:ext cx="1234440" cy="274320"/>
+          </a:xfrm>
+          <a:prstGeom prst="rect">
+            <a:avLst/>
+          </a:prstGeom>
+          <a:noFill/>
+          <a:ln/>
+        </p:spPr>
+        <p:txBody>
+          <a:bodyPr wrap="square" lIns="0" tIns="0" rIns="0" bIns="0" rtlCol="0" anchor="ctr"/>
+          <a:lstStyle/>
+          <a:p>
+            <a:pPr indent="0" marL="0">
+              <a:buNone/>
+            </a:pPr>
+            <a:r>
+              <a:rPr lang="en-US" sz="1200" b="1" dirty="0">
+                <a:solidFill>
+                  <a:srgbClr val="0F1E2E"/>
+                </a:solidFill>
+                <a:latin typeface="Calibri" pitchFamily="34" charset="0"/>
+                <a:ea typeface="Calibri" pitchFamily="34" charset="-122"/>
+                <a:cs typeface="Calibri" pitchFamily="34" charset="-120"/>
+              </a:rPr>
+              <a:t>10 Aug</a:t>
+            </a:r>
+            <a:endParaRPr lang="en-US" sz="1200" dirty="0"/>
+          </a:p>
+        </p:txBody>
+      </p:sp>
+      <p:sp>
+        <p:nvSpPr>
+          <p:cNvPr id="12" name="Text 10"/>
+          <p:cNvSpPr/>
+          <p:nvPr/>
+        </p:nvSpPr>
+        <p:spPr>
+          <a:xfrm>
+            <a:off x="2212848" y="2697480"/>
+            <a:ext cx="3291840" cy="502920"/>
+          </a:xfrm>
+          <a:prstGeom prst="rect">
+            <a:avLst/>
+          </a:prstGeom>
+          <a:noFill/>
+          <a:ln/>
+        </p:spPr>
+        <p:txBody>
+          <a:bodyPr wrap="square" lIns="0" tIns="0" rIns="0" bIns="0" rtlCol="0" anchor="ctr"/>
+          <a:lstStyle/>
+          <a:p>
+            <a:pPr indent="0" marL="0">
+              <a:lnSpc>
+                <a:spcPct val="105000"/>
+              </a:lnSpc>
+              <a:buNone/>
+            </a:pPr>
+            <a:r>
+              <a:rPr lang="en-US" sz="1150" dirty="0">
+                <a:solidFill>
+                  <a:srgbClr val="5A6B7A"/>
+                </a:solidFill>
+                <a:latin typeface="Calibri" pitchFamily="34" charset="0"/>
+                <a:ea typeface="Calibri" pitchFamily="34" charset="-122"/>
+                <a:cs typeface="Calibri" pitchFamily="34" charset="-120"/>
+              </a:rPr>
+              <a:t>Evaluation set drops — 333 questions, no answers.</a:t>
+            </a:r>
+            <a:endParaRPr lang="en-US" sz="1150" dirty="0"/>
+          </a:p>
+        </p:txBody>
+      </p:sp>
+      <p:sp>
+        <p:nvSpPr>
+          <p:cNvPr id="13" name="Shape 11"/>
+          <p:cNvSpPr/>
+          <p:nvPr/>
+        </p:nvSpPr>
+        <p:spPr>
+          <a:xfrm>
+            <a:off x="585216" y="3310128"/>
+            <a:ext cx="182880" cy="182880"/>
+          </a:xfrm>
+          <a:prstGeom prst="ellipse">
+            <a:avLst/>
+          </a:prstGeom>
+          <a:solidFill>
+            <a:srgbClr val="2A5C7A"/>
+          </a:solidFill>
+          <a:ln/>
+        </p:spPr>
+      </p:sp>
+      <p:sp>
+        <p:nvSpPr>
+          <p:cNvPr id="14" name="Shape 12"/>
+          <p:cNvSpPr/>
+          <p:nvPr/>
+        </p:nvSpPr>
+        <p:spPr>
+          <a:xfrm>
+            <a:off x="667512" y="3493008"/>
+            <a:ext cx="18288" cy="365760"/>
+          </a:xfrm>
+          <a:prstGeom prst="rect">
+            <a:avLst/>
+          </a:prstGeom>
+          <a:solidFill>
+            <a:srgbClr val="D5DEE5"/>
+          </a:solidFill>
+          <a:ln/>
+        </p:spPr>
+      </p:sp>
+      <p:sp>
+        <p:nvSpPr>
+          <p:cNvPr id="15" name="Text 13"/>
+          <p:cNvSpPr/>
+          <p:nvPr/>
+        </p:nvSpPr>
+        <p:spPr>
+          <a:xfrm>
+            <a:off x="932688" y="3246120"/>
+            <a:ext cx="1234440" cy="274320"/>
+          </a:xfrm>
+          <a:prstGeom prst="rect">
+            <a:avLst/>
+          </a:prstGeom>
+          <a:noFill/>
+          <a:ln/>
+        </p:spPr>
+        <p:txBody>
+          <a:bodyPr wrap="square" lIns="0" tIns="0" rIns="0" bIns="0" rtlCol="0" anchor="ctr"/>
+          <a:lstStyle/>
+          <a:p>
+            <a:pPr indent="0" marL="0">
+              <a:buNone/>
+            </a:pPr>
+            <a:r>
+              <a:rPr lang="en-US" sz="1200" b="1" dirty="0">
+                <a:solidFill>
+                  <a:srgbClr val="0F1E2E"/>
+                </a:solidFill>
+                <a:latin typeface="Calibri" pitchFamily="34" charset="0"/>
+                <a:ea typeface="Calibri" pitchFamily="34" charset="-122"/>
+                <a:cs typeface="Calibri" pitchFamily="34" charset="-120"/>
+              </a:rPr>
+              <a:t>11 Aug am</a:t>
+            </a:r>
+            <a:endParaRPr lang="en-US" sz="1200" dirty="0"/>
+          </a:p>
+        </p:txBody>
+      </p:sp>
+      <p:sp>
+        <p:nvSpPr>
+          <p:cNvPr id="16" name="Text 14"/>
+          <p:cNvSpPr/>
+          <p:nvPr/>
+        </p:nvSpPr>
+        <p:spPr>
+          <a:xfrm>
+            <a:off x="2212848" y="3246120"/>
+            <a:ext cx="3291840" cy="502920"/>
+          </a:xfrm>
+          <a:prstGeom prst="rect">
+            <a:avLst/>
+          </a:prstGeom>
+          <a:noFill/>
+          <a:ln/>
+        </p:spPr>
+        <p:txBody>
+          <a:bodyPr wrap="square" lIns="0" tIns="0" rIns="0" bIns="0" rtlCol="0" anchor="ctr"/>
+          <a:lstStyle/>
+          <a:p>
+            <a:pPr indent="0" marL="0">
+              <a:lnSpc>
+                <a:spcPct val="105000"/>
+              </a:lnSpc>
+              <a:buNone/>
+            </a:pPr>
+            <a:r>
+              <a:rPr lang="en-US" sz="1150" dirty="0">
+                <a:solidFill>
+                  <a:srgbClr val="5A6B7A"/>
+                </a:solidFill>
+                <a:latin typeface="Calibri" pitchFamily="34" charset="0"/>
+                <a:ea typeface="Calibri" pitchFamily="34" charset="-122"/>
+                <a:cs typeface="Calibri" pitchFamily="34" charset="-120"/>
+              </a:rPr>
+              <a:t>First scored run 49.822 — the question set had been revised under us.</a:t>
+            </a:r>
+            <a:endParaRPr lang="en-US" sz="1150" dirty="0"/>
+          </a:p>
+        </p:txBody>
+      </p:sp>
+      <p:sp>
+        <p:nvSpPr>
+          <p:cNvPr id="17" name="Shape 15"/>
+          <p:cNvSpPr/>
+          <p:nvPr/>
+        </p:nvSpPr>
+        <p:spPr>
+          <a:xfrm>
+            <a:off x="585216" y="3858768"/>
+            <a:ext cx="182880" cy="182880"/>
           </a:xfrm>
           <a:prstGeom prst="ellipse">
             <a:avLst/>
@@ -6986,30 +7559,50 @@
       </p:sp>
       <p:sp>
         <p:nvSpPr>
-          <p:cNvPr id="4" name="Text 2"/>
-          <p:cNvSpPr/>
-          <p:nvPr/>
-        </p:nvSpPr>
-        <p:spPr>
-          <a:xfrm>
-            <a:off x="566928" y="1600200"/>
-            <a:ext cx="402336" cy="402336"/>
-          </a:xfrm>
-          <a:prstGeom prst="rect">
-            <a:avLst/>
-          </a:prstGeom>
-          <a:noFill/>
-          <a:ln/>
-        </p:spPr>
-        <p:txBody>
-          <a:bodyPr wrap="square" lIns="0" tIns="0" rIns="0" bIns="0" rtlCol="0" anchor="ctr"/>
-          <a:lstStyle/>
-          <a:p>
-            <a:pPr algn="ctr" indent="0" marL="0">
-              <a:buNone/>
-            </a:pPr>
-            <a:r>
-              <a:rPr lang="en-US" sz="1500" b="1" dirty="0">
+          <p:cNvPr id="18" name="Shape 16"/>
+          <p:cNvSpPr/>
+          <p:nvPr/>
+        </p:nvSpPr>
+        <p:spPr>
+          <a:xfrm>
+            <a:off x="667512" y="4041648"/>
+            <a:ext cx="18288" cy="365760"/>
+          </a:xfrm>
+          <a:prstGeom prst="rect">
+            <a:avLst/>
+          </a:prstGeom>
+          <a:solidFill>
+            <a:srgbClr val="D5DEE5"/>
+          </a:solidFill>
+          <a:ln/>
+        </p:spPr>
+      </p:sp>
+      <p:sp>
+        <p:nvSpPr>
+          <p:cNvPr id="19" name="Text 17"/>
+          <p:cNvSpPr/>
+          <p:nvPr/>
+        </p:nvSpPr>
+        <p:spPr>
+          <a:xfrm>
+            <a:off x="932688" y="3794760"/>
+            <a:ext cx="1234440" cy="274320"/>
+          </a:xfrm>
+          <a:prstGeom prst="rect">
+            <a:avLst/>
+          </a:prstGeom>
+          <a:noFill/>
+          <a:ln/>
+        </p:spPr>
+        <p:txBody>
+          <a:bodyPr wrap="square" lIns="0" tIns="0" rIns="0" bIns="0" rtlCol="0" anchor="ctr"/>
+          <a:lstStyle/>
+          <a:p>
+            <a:pPr indent="0" marL="0">
+              <a:buNone/>
+            </a:pPr>
+            <a:r>
+              <a:rPr lang="en-US" sz="1200" b="1" dirty="0">
                 <a:solidFill>
                   <a:srgbClr val="0F1E2E"/>
                 </a:solidFill>
@@ -7017,61 +7610,22 @@
                 <a:ea typeface="Calibri" pitchFamily="34" charset="-122"/>
                 <a:cs typeface="Calibri" pitchFamily="34" charset="-120"/>
               </a:rPr>
-              <a:t>1</a:t>
-            </a:r>
-            <a:endParaRPr lang="en-US" sz="1500" dirty="0"/>
-          </a:p>
-        </p:txBody>
-      </p:sp>
-      <p:sp>
-        <p:nvSpPr>
-          <p:cNvPr id="5" name="Text 3"/>
-          <p:cNvSpPr/>
-          <p:nvPr/>
-        </p:nvSpPr>
-        <p:spPr>
-          <a:xfrm>
-            <a:off x="1188720" y="1554480"/>
-            <a:ext cx="10332720" cy="329184"/>
-          </a:xfrm>
-          <a:prstGeom prst="rect">
-            <a:avLst/>
-          </a:prstGeom>
-          <a:noFill/>
-          <a:ln/>
-        </p:spPr>
-        <p:txBody>
-          <a:bodyPr wrap="square" lIns="0" tIns="0" rIns="0" bIns="0" rtlCol="0" anchor="ctr"/>
-          <a:lstStyle/>
-          <a:p>
-            <a:pPr indent="0" marL="0">
-              <a:buNone/>
-            </a:pPr>
-            <a:r>
-              <a:rPr lang="en-US" sz="1700" b="1" dirty="0">
-                <a:solidFill>
-                  <a:srgbClr val="FFFFFF"/>
-                </a:solidFill>
-                <a:latin typeface="Calibri" pitchFamily="34" charset="0"/>
-                <a:ea typeface="Calibri" pitchFamily="34" charset="-122"/>
-                <a:cs typeface="Calibri" pitchFamily="34" charset="-120"/>
-              </a:rPr>
-              <a:t>Separate classification from computation</a:t>
-            </a:r>
-            <a:endParaRPr lang="en-US" sz="1700" dirty="0"/>
-          </a:p>
-        </p:txBody>
-      </p:sp>
-      <p:sp>
-        <p:nvSpPr>
-          <p:cNvPr id="6" name="Text 4"/>
-          <p:cNvSpPr/>
-          <p:nvPr/>
-        </p:nvSpPr>
-        <p:spPr>
-          <a:xfrm>
-            <a:off x="1188720" y="1901952"/>
-            <a:ext cx="10332720" cy="658368"/>
+              <a:t>11 Aug midday</a:t>
+            </a:r>
+            <a:endParaRPr lang="en-US" sz="1200" dirty="0"/>
+          </a:p>
+        </p:txBody>
+      </p:sp>
+      <p:sp>
+        <p:nvSpPr>
+          <p:cNvPr id="20" name="Text 18"/>
+          <p:cNvSpPr/>
+          <p:nvPr/>
+        </p:nvSpPr>
+        <p:spPr>
+          <a:xfrm>
+            <a:off x="2212848" y="3794760"/>
+            <a:ext cx="3291840" cy="502920"/>
           </a:xfrm>
           <a:prstGeom prst="rect">
             <a:avLst/>
@@ -7085,35 +7639,35 @@
           <a:p>
             <a:pPr indent="0" marL="0">
               <a:lnSpc>
-                <a:spcPct val="115000"/>
+                <a:spcPct val="105000"/>
               </a:lnSpc>
               <a:buNone/>
             </a:pPr>
             <a:r>
-              <a:rPr lang="en-US" sz="1300" dirty="0">
-                <a:solidFill>
-                  <a:srgbClr val="9FB3C2"/>
-                </a:solidFill>
-                <a:latin typeface="Calibri" pitchFamily="34" charset="0"/>
-                <a:ea typeface="Calibri" pitchFamily="34" charset="-122"/>
-                <a:cs typeface="Calibri" pitchFamily="34" charset="-120"/>
-              </a:rPr>
-              <a:t>Let the model decide WHAT to compute and never compute it. Every number stays reproducible, auditable, and exactly as precise as the source document.</a:t>
-            </a:r>
-            <a:endParaRPr lang="en-US" sz="1300" dirty="0"/>
-          </a:p>
-        </p:txBody>
-      </p:sp>
-      <p:sp>
-        <p:nvSpPr>
-          <p:cNvPr id="7" name="Shape 5"/>
-          <p:cNvSpPr/>
-          <p:nvPr/>
-        </p:nvSpPr>
-        <p:spPr>
-          <a:xfrm>
-            <a:off x="566928" y="2770632"/>
-            <a:ext cx="402336" cy="402336"/>
+              <a:rPr lang="en-US" sz="1150" dirty="0">
+                <a:solidFill>
+                  <a:srgbClr val="5A6B7A"/>
+                </a:solidFill>
+                <a:latin typeface="Calibri" pitchFamily="34" charset="0"/>
+                <a:ea typeface="Calibri" pitchFamily="34" charset="-122"/>
+                <a:cs typeface="Calibri" pitchFamily="34" charset="-120"/>
+              </a:rPr>
+              <a:t>Rule ladder replaced by the family classifier. 73.0 → 98.1.</a:t>
+            </a:r>
+            <a:endParaRPr lang="en-US" sz="1150" dirty="0"/>
+          </a:p>
+        </p:txBody>
+      </p:sp>
+      <p:sp>
+        <p:nvSpPr>
+          <p:cNvPr id="21" name="Shape 19"/>
+          <p:cNvSpPr/>
+          <p:nvPr/>
+        </p:nvSpPr>
+        <p:spPr>
+          <a:xfrm>
+            <a:off x="585216" y="4407408"/>
+            <a:ext cx="182880" cy="182880"/>
           </a:xfrm>
           <a:prstGeom prst="ellipse">
             <a:avLst/>
@@ -7126,30 +7680,50 @@
       </p:sp>
       <p:sp>
         <p:nvSpPr>
-          <p:cNvPr id="8" name="Text 6"/>
-          <p:cNvSpPr/>
-          <p:nvPr/>
-        </p:nvSpPr>
-        <p:spPr>
-          <a:xfrm>
-            <a:off x="566928" y="2770632"/>
-            <a:ext cx="402336" cy="402336"/>
-          </a:xfrm>
-          <a:prstGeom prst="rect">
-            <a:avLst/>
-          </a:prstGeom>
-          <a:noFill/>
-          <a:ln/>
-        </p:spPr>
-        <p:txBody>
-          <a:bodyPr wrap="square" lIns="0" tIns="0" rIns="0" bIns="0" rtlCol="0" anchor="ctr"/>
-          <a:lstStyle/>
-          <a:p>
-            <a:pPr algn="ctr" indent="0" marL="0">
-              <a:buNone/>
-            </a:pPr>
-            <a:r>
-              <a:rPr lang="en-US" sz="1500" b="1" dirty="0">
+          <p:cNvPr id="22" name="Shape 20"/>
+          <p:cNvSpPr/>
+          <p:nvPr/>
+        </p:nvSpPr>
+        <p:spPr>
+          <a:xfrm>
+            <a:off x="667512" y="4590288"/>
+            <a:ext cx="18288" cy="365760"/>
+          </a:xfrm>
+          <a:prstGeom prst="rect">
+            <a:avLst/>
+          </a:prstGeom>
+          <a:solidFill>
+            <a:srgbClr val="D5DEE5"/>
+          </a:solidFill>
+          <a:ln/>
+        </p:spPr>
+      </p:sp>
+      <p:sp>
+        <p:nvSpPr>
+          <p:cNvPr id="23" name="Text 21"/>
+          <p:cNvSpPr/>
+          <p:nvPr/>
+        </p:nvSpPr>
+        <p:spPr>
+          <a:xfrm>
+            <a:off x="932688" y="4343400"/>
+            <a:ext cx="1234440" cy="274320"/>
+          </a:xfrm>
+          <a:prstGeom prst="rect">
+            <a:avLst/>
+          </a:prstGeom>
+          <a:noFill/>
+          <a:ln/>
+        </p:spPr>
+        <p:txBody>
+          <a:bodyPr wrap="square" lIns="0" tIns="0" rIns="0" bIns="0" rtlCol="0" anchor="ctr"/>
+          <a:lstStyle/>
+          <a:p>
+            <a:pPr indent="0" marL="0">
+              <a:buNone/>
+            </a:pPr>
+            <a:r>
+              <a:rPr lang="en-US" sz="1200" b="1" dirty="0">
                 <a:solidFill>
                   <a:srgbClr val="0F1E2E"/>
                 </a:solidFill>
@@ -7157,38 +7731,344 @@
                 <a:ea typeface="Calibri" pitchFamily="34" charset="-122"/>
                 <a:cs typeface="Calibri" pitchFamily="34" charset="-120"/>
               </a:rPr>
-              <a:t>2</a:t>
-            </a:r>
-            <a:endParaRPr lang="en-US" sz="1500" dirty="0"/>
-          </a:p>
-        </p:txBody>
-      </p:sp>
-      <p:sp>
-        <p:nvSpPr>
-          <p:cNvPr id="9" name="Text 7"/>
-          <p:cNvSpPr/>
-          <p:nvPr/>
-        </p:nvSpPr>
-        <p:spPr>
-          <a:xfrm>
-            <a:off x="1188720" y="2724912"/>
-            <a:ext cx="10332720" cy="329184"/>
-          </a:xfrm>
-          <a:prstGeom prst="rect">
-            <a:avLst/>
-          </a:prstGeom>
-          <a:noFill/>
-          <a:ln/>
-        </p:spPr>
-        <p:txBody>
-          <a:bodyPr wrap="square" lIns="0" tIns="0" rIns="0" bIns="0" rtlCol="0" anchor="ctr"/>
-          <a:lstStyle/>
-          <a:p>
-            <a:pPr indent="0" marL="0">
-              <a:buNone/>
-            </a:pPr>
-            <a:r>
-              <a:rPr lang="en-US" sz="1700" b="1" dirty="0">
+              <a:t>11 Aug pm</a:t>
+            </a:r>
+            <a:endParaRPr lang="en-US" sz="1200" dirty="0"/>
+          </a:p>
+        </p:txBody>
+      </p:sp>
+      <p:sp>
+        <p:nvSpPr>
+          <p:cNvPr id="24" name="Text 22"/>
+          <p:cNvSpPr/>
+          <p:nvPr/>
+        </p:nvSpPr>
+        <p:spPr>
+          <a:xfrm>
+            <a:off x="2212848" y="4343400"/>
+            <a:ext cx="3291840" cy="502920"/>
+          </a:xfrm>
+          <a:prstGeom prst="rect">
+            <a:avLst/>
+          </a:prstGeom>
+          <a:noFill/>
+          <a:ln/>
+        </p:spPr>
+        <p:txBody>
+          <a:bodyPr wrap="square" lIns="0" tIns="0" rIns="0" bIns="0" rtlCol="0" anchor="ctr"/>
+          <a:lstStyle/>
+          <a:p>
+            <a:pPr indent="0" marL="0">
+              <a:lnSpc>
+                <a:spcPct val="105000"/>
+              </a:lnSpc>
+              <a:buNone/>
+            </a:pPr>
+            <a:r>
+              <a:rPr lang="en-US" sz="1150" dirty="0">
+                <a:solidFill>
+                  <a:srgbClr val="5A6B7A"/>
+                </a:solidFill>
+                <a:latin typeface="Calibri" pitchFamily="34" charset="0"/>
+                <a:ea typeface="Calibri" pitchFamily="34" charset="-122"/>
+                <a:cs typeface="Calibri" pitchFamily="34" charset="-120"/>
+              </a:rPr>
+              <a:t>Cross-checks and leaderboard measurement. 98.1 → 100.000.</a:t>
+            </a:r>
+            <a:endParaRPr lang="en-US" sz="1150" dirty="0"/>
+          </a:p>
+        </p:txBody>
+      </p:sp>
+      <p:sp>
+        <p:nvSpPr>
+          <p:cNvPr id="25" name="Shape 23"/>
+          <p:cNvSpPr/>
+          <p:nvPr/>
+        </p:nvSpPr>
+        <p:spPr>
+          <a:xfrm>
+            <a:off x="585216" y="4956048"/>
+            <a:ext cx="182880" cy="182880"/>
+          </a:xfrm>
+          <a:prstGeom prst="ellipse">
+            <a:avLst/>
+          </a:prstGeom>
+          <a:solidFill>
+            <a:srgbClr val="2A5C7A"/>
+          </a:solidFill>
+          <a:ln/>
+        </p:spPr>
+      </p:sp>
+      <p:sp>
+        <p:nvSpPr>
+          <p:cNvPr id="26" name="Shape 24"/>
+          <p:cNvSpPr/>
+          <p:nvPr/>
+        </p:nvSpPr>
+        <p:spPr>
+          <a:xfrm>
+            <a:off x="667512" y="5138928"/>
+            <a:ext cx="18288" cy="365760"/>
+          </a:xfrm>
+          <a:prstGeom prst="rect">
+            <a:avLst/>
+          </a:prstGeom>
+          <a:solidFill>
+            <a:srgbClr val="D5DEE5"/>
+          </a:solidFill>
+          <a:ln/>
+        </p:spPr>
+      </p:sp>
+      <p:sp>
+        <p:nvSpPr>
+          <p:cNvPr id="27" name="Text 25"/>
+          <p:cNvSpPr/>
+          <p:nvPr/>
+        </p:nvSpPr>
+        <p:spPr>
+          <a:xfrm>
+            <a:off x="932688" y="4892040"/>
+            <a:ext cx="1234440" cy="274320"/>
+          </a:xfrm>
+          <a:prstGeom prst="rect">
+            <a:avLst/>
+          </a:prstGeom>
+          <a:noFill/>
+          <a:ln/>
+        </p:spPr>
+        <p:txBody>
+          <a:bodyPr wrap="square" lIns="0" tIns="0" rIns="0" bIns="0" rtlCol="0" anchor="ctr"/>
+          <a:lstStyle/>
+          <a:p>
+            <a:pPr indent="0" marL="0">
+              <a:buNone/>
+            </a:pPr>
+            <a:r>
+              <a:rPr lang="en-US" sz="1200" b="1" dirty="0">
+                <a:solidFill>
+                  <a:srgbClr val="0F1E2E"/>
+                </a:solidFill>
+                <a:latin typeface="Calibri" pitchFamily="34" charset="0"/>
+                <a:ea typeface="Calibri" pitchFamily="34" charset="-122"/>
+                <a:cs typeface="Calibri" pitchFamily="34" charset="-120"/>
+              </a:rPr>
+              <a:t>13 Aug</a:t>
+            </a:r>
+            <a:endParaRPr lang="en-US" sz="1200" dirty="0"/>
+          </a:p>
+        </p:txBody>
+      </p:sp>
+      <p:sp>
+        <p:nvSpPr>
+          <p:cNvPr id="28" name="Text 26"/>
+          <p:cNvSpPr/>
+          <p:nvPr/>
+        </p:nvSpPr>
+        <p:spPr>
+          <a:xfrm>
+            <a:off x="2212848" y="4892040"/>
+            <a:ext cx="3291840" cy="502920"/>
+          </a:xfrm>
+          <a:prstGeom prst="rect">
+            <a:avLst/>
+          </a:prstGeom>
+          <a:noFill/>
+          <a:ln/>
+        </p:spPr>
+        <p:txBody>
+          <a:bodyPr wrap="square" lIns="0" tIns="0" rIns="0" bIns="0" rtlCol="0" anchor="ctr"/>
+          <a:lstStyle/>
+          <a:p>
+            <a:pPr indent="0" marL="0">
+              <a:lnSpc>
+                <a:spcPct val="105000"/>
+              </a:lnSpc>
+              <a:buNone/>
+            </a:pPr>
+            <a:r>
+              <a:rPr lang="en-US" sz="1150" dirty="0">
+                <a:solidFill>
+                  <a:srgbClr val="5A6B7A"/>
+                </a:solidFill>
+                <a:latin typeface="Calibri" pitchFamily="34" charset="0"/>
+                <a:ea typeface="Calibri" pitchFamily="34" charset="-122"/>
+                <a:cs typeface="Calibri" pitchFamily="34" charset="-120"/>
+              </a:rPr>
+              <a:t>Submission deadline.</a:t>
+            </a:r>
+            <a:endParaRPr lang="en-US" sz="1150" dirty="0"/>
+          </a:p>
+        </p:txBody>
+      </p:sp>
+      <p:sp>
+        <p:nvSpPr>
+          <p:cNvPr id="29" name="Shape 27"/>
+          <p:cNvSpPr/>
+          <p:nvPr/>
+        </p:nvSpPr>
+        <p:spPr>
+          <a:xfrm>
+            <a:off x="585216" y="5504688"/>
+            <a:ext cx="182880" cy="182880"/>
+          </a:xfrm>
+          <a:prstGeom prst="ellipse">
+            <a:avLst/>
+          </a:prstGeom>
+          <a:solidFill>
+            <a:srgbClr val="2A5C7A"/>
+          </a:solidFill>
+          <a:ln/>
+        </p:spPr>
+      </p:sp>
+      <p:sp>
+        <p:nvSpPr>
+          <p:cNvPr id="30" name="Text 28"/>
+          <p:cNvSpPr/>
+          <p:nvPr/>
+        </p:nvSpPr>
+        <p:spPr>
+          <a:xfrm>
+            <a:off x="932688" y="5440680"/>
+            <a:ext cx="1234440" cy="274320"/>
+          </a:xfrm>
+          <a:prstGeom prst="rect">
+            <a:avLst/>
+          </a:prstGeom>
+          <a:noFill/>
+          <a:ln/>
+        </p:spPr>
+        <p:txBody>
+          <a:bodyPr wrap="square" lIns="0" tIns="0" rIns="0" bIns="0" rtlCol="0" anchor="ctr"/>
+          <a:lstStyle/>
+          <a:p>
+            <a:pPr indent="0" marL="0">
+              <a:buNone/>
+            </a:pPr>
+            <a:r>
+              <a:rPr lang="en-US" sz="1200" b="1" dirty="0">
+                <a:solidFill>
+                  <a:srgbClr val="0F1E2E"/>
+                </a:solidFill>
+                <a:latin typeface="Calibri" pitchFamily="34" charset="0"/>
+                <a:ea typeface="Calibri" pitchFamily="34" charset="-122"/>
+                <a:cs typeface="Calibri" pitchFamily="34" charset="-120"/>
+              </a:rPr>
+              <a:t>15 Aug</a:t>
+            </a:r>
+            <a:endParaRPr lang="en-US" sz="1200" dirty="0"/>
+          </a:p>
+        </p:txBody>
+      </p:sp>
+      <p:sp>
+        <p:nvSpPr>
+          <p:cNvPr id="31" name="Text 29"/>
+          <p:cNvSpPr/>
+          <p:nvPr/>
+        </p:nvSpPr>
+        <p:spPr>
+          <a:xfrm>
+            <a:off x="2212848" y="5440680"/>
+            <a:ext cx="3291840" cy="502920"/>
+          </a:xfrm>
+          <a:prstGeom prst="rect">
+            <a:avLst/>
+          </a:prstGeom>
+          <a:noFill/>
+          <a:ln/>
+        </p:spPr>
+        <p:txBody>
+          <a:bodyPr wrap="square" lIns="0" tIns="0" rIns="0" bIns="0" rtlCol="0" anchor="ctr"/>
+          <a:lstStyle/>
+          <a:p>
+            <a:pPr indent="0" marL="0">
+              <a:lnSpc>
+                <a:spcPct val="105000"/>
+              </a:lnSpc>
+              <a:buNone/>
+            </a:pPr>
+            <a:r>
+              <a:rPr lang="en-US" sz="1150" dirty="0">
+                <a:solidFill>
+                  <a:srgbClr val="5A6B7A"/>
+                </a:solidFill>
+                <a:latin typeface="Calibri" pitchFamily="34" charset="0"/>
+                <a:ea typeface="Calibri" pitchFamily="34" charset="-122"/>
+                <a:cs typeface="Calibri" pitchFamily="34" charset="-120"/>
+              </a:rPr>
+              <a:t>This session.</a:t>
+            </a:r>
+            <a:endParaRPr lang="en-US" sz="1150" dirty="0"/>
+          </a:p>
+        </p:txBody>
+      </p:sp>
+      <p:sp>
+        <p:nvSpPr>
+          <p:cNvPr id="32" name="Shape 30"/>
+          <p:cNvSpPr/>
+          <p:nvPr/>
+        </p:nvSpPr>
+        <p:spPr>
+          <a:xfrm>
+            <a:off x="5961888" y="1783080"/>
+            <a:ext cx="2788920" cy="4069080"/>
+          </a:xfrm>
+          <a:prstGeom prst="roundRect">
+            <a:avLst>
+              <a:gd name="adj" fmla="val 2623"/>
+            </a:avLst>
+          </a:prstGeom>
+          <a:solidFill>
+            <a:srgbClr val="F4F6F8"/>
+          </a:solidFill>
+          <a:ln/>
+        </p:spPr>
+      </p:sp>
+      <p:sp>
+        <p:nvSpPr>
+          <p:cNvPr id="33" name="Shape 31"/>
+          <p:cNvSpPr/>
+          <p:nvPr/>
+        </p:nvSpPr>
+        <p:spPr>
+          <a:xfrm>
+            <a:off x="5961888" y="1783080"/>
+            <a:ext cx="2788920" cy="841248"/>
+          </a:xfrm>
+          <a:prstGeom prst="rect">
+            <a:avLst/>
+          </a:prstGeom>
+          <a:solidFill>
+            <a:srgbClr val="0F1E2E"/>
+          </a:solidFill>
+          <a:ln/>
+        </p:spPr>
+      </p:sp>
+      <p:sp>
+        <p:nvSpPr>
+          <p:cNvPr id="34" name="Text 32"/>
+          <p:cNvSpPr/>
+          <p:nvPr/>
+        </p:nvSpPr>
+        <p:spPr>
+          <a:xfrm>
+            <a:off x="6126480" y="1874520"/>
+            <a:ext cx="2468880" cy="292608"/>
+          </a:xfrm>
+          <a:prstGeom prst="rect">
+            <a:avLst/>
+          </a:prstGeom>
+          <a:noFill/>
+          <a:ln/>
+        </p:spPr>
+        <p:txBody>
+          <a:bodyPr wrap="square" lIns="0" tIns="0" rIns="0" bIns="0" rtlCol="0" anchor="ctr"/>
+          <a:lstStyle/>
+          <a:p>
+            <a:pPr indent="0" marL="0">
+              <a:buNone/>
+            </a:pPr>
+            <a:r>
+              <a:rPr lang="en-US" sz="1400" b="1" dirty="0">
                 <a:solidFill>
                   <a:srgbClr val="FFFFFF"/>
                 </a:solidFill>
@@ -7196,22 +8076,22 @@
                 <a:ea typeface="Calibri" pitchFamily="34" charset="-122"/>
                 <a:cs typeface="Calibri" pitchFamily="34" charset="-120"/>
               </a:rPr>
-              <a:t>Corroborate the data layer first</a:t>
-            </a:r>
-            <a:endParaRPr lang="en-US" sz="1700" dirty="0"/>
-          </a:p>
-        </p:txBody>
-      </p:sp>
-      <p:sp>
-        <p:nvSpPr>
-          <p:cNvPr id="10" name="Text 8"/>
-          <p:cNvSpPr/>
-          <p:nvPr/>
-        </p:nvSpPr>
-        <p:spPr>
-          <a:xfrm>
-            <a:off x="1188720" y="3072384"/>
-            <a:ext cx="10332720" cy="658368"/>
+              <a:t>[ NAME 1 ]</a:t>
+            </a:r>
+            <a:endParaRPr lang="en-US" sz="1400" dirty="0"/>
+          </a:p>
+        </p:txBody>
+      </p:sp>
+      <p:sp>
+        <p:nvSpPr>
+          <p:cNvPr id="35" name="Text 33"/>
+          <p:cNvSpPr/>
+          <p:nvPr/>
+        </p:nvSpPr>
+        <p:spPr>
+          <a:xfrm>
+            <a:off x="6126480" y="2194560"/>
+            <a:ext cx="2468880" cy="347472"/>
           </a:xfrm>
           <a:prstGeom prst="rect">
             <a:avLst/>
@@ -7225,35 +8105,35 @@
           <a:p>
             <a:pPr indent="0" marL="0">
               <a:lnSpc>
-                <a:spcPct val="115000"/>
+                <a:spcPct val="105000"/>
               </a:lnSpc>
               <a:buNone/>
             </a:pPr>
             <a:r>
-              <a:rPr lang="en-US" sz="1300" dirty="0">
-                <a:solidFill>
-                  <a:srgbClr val="9FB3C2"/>
-                </a:solidFill>
-                <a:latin typeface="Calibri" pitchFamily="34" charset="0"/>
-                <a:ea typeface="Calibri" pitchFamily="34" charset="-122"/>
-                <a:cs typeface="Calibri" pitchFamily="34" charset="-120"/>
-              </a:rPr>
-              <a:t>Extracting the same facts twice by different routes cost a day and bought the deduction that every later error had to be in the query layer.</a:t>
-            </a:r>
-            <a:endParaRPr lang="en-US" sz="1300" dirty="0"/>
-          </a:p>
-        </p:txBody>
-      </p:sp>
-      <p:sp>
-        <p:nvSpPr>
-          <p:cNvPr id="11" name="Shape 9"/>
-          <p:cNvSpPr/>
-          <p:nvPr/>
-        </p:nvSpPr>
-        <p:spPr>
-          <a:xfrm>
-            <a:off x="566928" y="3941064"/>
-            <a:ext cx="402336" cy="402336"/>
+              <a:rPr lang="en-US" sz="1150" dirty="0">
+                <a:solidFill>
+                  <a:srgbClr val="F2A104"/>
+                </a:solidFill>
+                <a:latin typeface="Calibri" pitchFamily="34" charset="0"/>
+                <a:ea typeface="Calibri" pitchFamily="34" charset="-122"/>
+                <a:cs typeface="Calibri" pitchFamily="34" charset="-120"/>
+              </a:rPr>
+              <a:t>Extraction and data layer</a:t>
+            </a:r>
+            <a:endParaRPr lang="en-US" sz="1150" dirty="0"/>
+          </a:p>
+        </p:txBody>
+      </p:sp>
+      <p:sp>
+        <p:nvSpPr>
+          <p:cNvPr id="36" name="Shape 34"/>
+          <p:cNvSpPr/>
+          <p:nvPr/>
+        </p:nvSpPr>
+        <p:spPr>
+          <a:xfrm>
+            <a:off x="6126480" y="2852928"/>
+            <a:ext cx="100584" cy="100584"/>
           </a:xfrm>
           <a:prstGeom prst="ellipse">
             <a:avLst/>
@@ -7266,30 +8146,33 @@
       </p:sp>
       <p:sp>
         <p:nvSpPr>
-          <p:cNvPr id="12" name="Text 10"/>
-          <p:cNvSpPr/>
-          <p:nvPr/>
-        </p:nvSpPr>
-        <p:spPr>
-          <a:xfrm>
-            <a:off x="566928" y="3941064"/>
-            <a:ext cx="402336" cy="402336"/>
-          </a:xfrm>
-          <a:prstGeom prst="rect">
-            <a:avLst/>
-          </a:prstGeom>
-          <a:noFill/>
-          <a:ln/>
-        </p:spPr>
-        <p:txBody>
-          <a:bodyPr wrap="square" lIns="0" tIns="0" rIns="0" bIns="0" rtlCol="0" anchor="ctr"/>
-          <a:lstStyle/>
-          <a:p>
-            <a:pPr algn="ctr" indent="0" marL="0">
-              <a:buNone/>
-            </a:pPr>
-            <a:r>
-              <a:rPr lang="en-US" sz="1500" b="1" dirty="0">
+          <p:cNvPr id="37" name="Text 35"/>
+          <p:cNvSpPr/>
+          <p:nvPr/>
+        </p:nvSpPr>
+        <p:spPr>
+          <a:xfrm>
+            <a:off x="6345936" y="2788920"/>
+            <a:ext cx="2240280" cy="713232"/>
+          </a:xfrm>
+          <a:prstGeom prst="rect">
+            <a:avLst/>
+          </a:prstGeom>
+          <a:noFill/>
+          <a:ln/>
+        </p:spPr>
+        <p:txBody>
+          <a:bodyPr wrap="square" lIns="0" tIns="0" rIns="0" bIns="0" rtlCol="0" anchor="ctr"/>
+          <a:lstStyle/>
+          <a:p>
+            <a:pPr indent="0" marL="0">
+              <a:lnSpc>
+                <a:spcPct val="108000"/>
+              </a:lnSpc>
+              <a:buNone/>
+            </a:pPr>
+            <a:r>
+              <a:rPr lang="en-US" sz="1050" dirty="0">
                 <a:solidFill>
                   <a:srgbClr val="0F1E2E"/>
                 </a:solidFill>
@@ -7297,103 +8180,22 @@
                 <a:ea typeface="Calibri" pitchFamily="34" charset="-122"/>
                 <a:cs typeface="Calibri" pitchFamily="34" charset="-120"/>
               </a:rPr>
-              <a:t>3</a:t>
-            </a:r>
-            <a:endParaRPr lang="en-US" sz="1500" dirty="0"/>
-          </a:p>
-        </p:txBody>
-      </p:sp>
-      <p:sp>
-        <p:nvSpPr>
-          <p:cNvPr id="13" name="Text 11"/>
-          <p:cNvSpPr/>
-          <p:nvPr/>
-        </p:nvSpPr>
-        <p:spPr>
-          <a:xfrm>
-            <a:off x="1188720" y="3895344"/>
-            <a:ext cx="10332720" cy="329184"/>
-          </a:xfrm>
-          <a:prstGeom prst="rect">
-            <a:avLst/>
-          </a:prstGeom>
-          <a:noFill/>
-          <a:ln/>
-        </p:spPr>
-        <p:txBody>
-          <a:bodyPr wrap="square" lIns="0" tIns="0" rIns="0" bIns="0" rtlCol="0" anchor="ctr"/>
-          <a:lstStyle/>
-          <a:p>
-            <a:pPr indent="0" marL="0">
-              <a:buNone/>
-            </a:pPr>
-            <a:r>
-              <a:rPr lang="en-US" sz="1700" b="1" dirty="0">
-                <a:solidFill>
-                  <a:srgbClr val="FFFFFF"/>
-                </a:solidFill>
-                <a:latin typeface="Calibri" pitchFamily="34" charset="0"/>
-                <a:ea typeface="Calibri" pitchFamily="34" charset="-122"/>
-                <a:cs typeface="Calibri" pitchFamily="34" charset="-120"/>
-              </a:rPr>
-              <a:t>Find invariants that need no answer key</a:t>
-            </a:r>
-            <a:endParaRPr lang="en-US" sz="1700" dirty="0"/>
-          </a:p>
-        </p:txBody>
-      </p:sp>
-      <p:sp>
-        <p:nvSpPr>
-          <p:cNvPr id="14" name="Text 12"/>
-          <p:cNvSpPr/>
-          <p:nvPr/>
-        </p:nvSpPr>
-        <p:spPr>
-          <a:xfrm>
-            <a:off x="1188720" y="4242816"/>
-            <a:ext cx="10332720" cy="658368"/>
-          </a:xfrm>
-          <a:prstGeom prst="rect">
-            <a:avLst/>
-          </a:prstGeom>
-          <a:noFill/>
-          <a:ln/>
-        </p:spPr>
-        <p:txBody>
-          <a:bodyPr wrap="square" lIns="0" tIns="0" rIns="0" bIns="0" rtlCol="0" anchor="ctr"/>
-          <a:lstStyle/>
-          <a:p>
-            <a:pPr indent="0" marL="0">
-              <a:lnSpc>
-                <a:spcPct val="115000"/>
-              </a:lnSpc>
-              <a:buNone/>
-            </a:pPr>
-            <a:r>
-              <a:rPr lang="en-US" sz="1300" dirty="0">
-                <a:solidFill>
-                  <a:srgbClr val="9FB3C2"/>
-                </a:solidFill>
-                <a:latin typeface="Calibri" pitchFamily="34" charset="0"/>
-                <a:ea typeface="Calibri" pitchFamily="34" charset="-122"/>
-                <a:cs typeface="Calibri" pitchFamily="34" charset="-120"/>
-              </a:rPr>
-              <a:t>“A question naming a package is about that package's client” found three silent wrong answers with zero gold data.</a:t>
-            </a:r>
-            <a:endParaRPr lang="en-US" sz="1300" dirty="0"/>
-          </a:p>
-        </p:txBody>
-      </p:sp>
-      <p:sp>
-        <p:nvSpPr>
-          <p:cNvPr id="15" name="Shape 13"/>
-          <p:cNvSpPr/>
-          <p:nvPr/>
-        </p:nvSpPr>
-        <p:spPr>
-          <a:xfrm>
-            <a:off x="566928" y="5111496"/>
-            <a:ext cx="402336" cy="402336"/>
+              <a:t>PyMuPDF text pipeline over 678 PDFs; 7 certificate layouts plus prose fallbacks</a:t>
+            </a:r>
+            <a:endParaRPr lang="en-US" sz="1050" dirty="0"/>
+          </a:p>
+        </p:txBody>
+      </p:sp>
+      <p:sp>
+        <p:nvSpPr>
+          <p:cNvPr id="38" name="Shape 36"/>
+          <p:cNvSpPr/>
+          <p:nvPr/>
+        </p:nvSpPr>
+        <p:spPr>
+          <a:xfrm>
+            <a:off x="6126480" y="3611880"/>
+            <a:ext cx="100584" cy="100584"/>
           </a:xfrm>
           <a:prstGeom prst="ellipse">
             <a:avLst/>
@@ -7406,30 +8208,33 @@
       </p:sp>
       <p:sp>
         <p:nvSpPr>
-          <p:cNvPr id="16" name="Text 14"/>
-          <p:cNvSpPr/>
-          <p:nvPr/>
-        </p:nvSpPr>
-        <p:spPr>
-          <a:xfrm>
-            <a:off x="566928" y="5111496"/>
-            <a:ext cx="402336" cy="402336"/>
-          </a:xfrm>
-          <a:prstGeom prst="rect">
-            <a:avLst/>
-          </a:prstGeom>
-          <a:noFill/>
-          <a:ln/>
-        </p:spPr>
-        <p:txBody>
-          <a:bodyPr wrap="square" lIns="0" tIns="0" rIns="0" bIns="0" rtlCol="0" anchor="ctr"/>
-          <a:lstStyle/>
-          <a:p>
-            <a:pPr algn="ctr" indent="0" marL="0">
-              <a:buNone/>
-            </a:pPr>
-            <a:r>
-              <a:rPr lang="en-US" sz="1500" b="1" dirty="0">
+          <p:cNvPr id="39" name="Text 37"/>
+          <p:cNvSpPr/>
+          <p:nvPr/>
+        </p:nvSpPr>
+        <p:spPr>
+          <a:xfrm>
+            <a:off x="6345936" y="3547872"/>
+            <a:ext cx="2240280" cy="713232"/>
+          </a:xfrm>
+          <a:prstGeom prst="rect">
+            <a:avLst/>
+          </a:prstGeom>
+          <a:noFill/>
+          <a:ln/>
+        </p:spPr>
+        <p:txBody>
+          <a:bodyPr wrap="square" lIns="0" tIns="0" rIns="0" bIns="0" rtlCol="0" anchor="ctr"/>
+          <a:lstStyle/>
+          <a:p>
+            <a:pPr indent="0" marL="0">
+              <a:lnSpc>
+                <a:spcPct val="108000"/>
+              </a:lnSpc>
+              <a:buNone/>
+            </a:pPr>
+            <a:r>
+              <a:rPr lang="en-US" sz="1050" dirty="0">
                 <a:solidFill>
                   <a:srgbClr val="0F1E2E"/>
                 </a:solidFill>
@@ -7437,38 +8242,204 @@
                 <a:ea typeface="Calibri" pitchFamily="34" charset="-122"/>
                 <a:cs typeface="Calibri" pitchFamily="34" charset="-120"/>
               </a:rPr>
-              <a:t>4</a:t>
-            </a:r>
-            <a:endParaRPr lang="en-US" sz="1500" dirty="0"/>
-          </a:p>
-        </p:txBody>
-      </p:sp>
-      <p:sp>
-        <p:nvSpPr>
-          <p:cNvPr id="17" name="Text 15"/>
-          <p:cNvSpPr/>
-          <p:nvPr/>
-        </p:nvSpPr>
-        <p:spPr>
-          <a:xfrm>
-            <a:off x="1188720" y="5065776"/>
-            <a:ext cx="10332720" cy="329184"/>
-          </a:xfrm>
-          <a:prstGeom prst="rect">
-            <a:avLst/>
-          </a:prstGeom>
-          <a:noFill/>
-          <a:ln/>
-        </p:spPr>
-        <p:txBody>
-          <a:bodyPr wrap="square" lIns="0" tIns="0" rIns="0" bIns="0" rtlCol="0" anchor="ctr"/>
-          <a:lstStyle/>
-          <a:p>
-            <a:pPr indent="0" marL="0">
-              <a:buNone/>
-            </a:pPr>
-            <a:r>
-              <a:rPr lang="en-US" sz="1700" b="1" dirty="0">
+              <a:t>Entity resolution: 51 raw name strings → 28 clients, 39 people</a:t>
+            </a:r>
+            <a:endParaRPr lang="en-US" sz="1050" dirty="0"/>
+          </a:p>
+        </p:txBody>
+      </p:sp>
+      <p:sp>
+        <p:nvSpPr>
+          <p:cNvPr id="40" name="Shape 38"/>
+          <p:cNvSpPr/>
+          <p:nvPr/>
+        </p:nvSpPr>
+        <p:spPr>
+          <a:xfrm>
+            <a:off x="6126480" y="4370832"/>
+            <a:ext cx="100584" cy="100584"/>
+          </a:xfrm>
+          <a:prstGeom prst="ellipse">
+            <a:avLst/>
+          </a:prstGeom>
+          <a:solidFill>
+            <a:srgbClr val="F2A104"/>
+          </a:solidFill>
+          <a:ln/>
+        </p:spPr>
+      </p:sp>
+      <p:sp>
+        <p:nvSpPr>
+          <p:cNvPr id="41" name="Text 39"/>
+          <p:cNvSpPr/>
+          <p:nvPr/>
+        </p:nvSpPr>
+        <p:spPr>
+          <a:xfrm>
+            <a:off x="6345936" y="4306824"/>
+            <a:ext cx="2240280" cy="713232"/>
+          </a:xfrm>
+          <a:prstGeom prst="rect">
+            <a:avLst/>
+          </a:prstGeom>
+          <a:noFill/>
+          <a:ln/>
+        </p:spPr>
+        <p:txBody>
+          <a:bodyPr wrap="square" lIns="0" tIns="0" rIns="0" bIns="0" rtlCol="0" anchor="ctr"/>
+          <a:lstStyle/>
+          <a:p>
+            <a:pPr indent="0" marL="0">
+              <a:lnSpc>
+                <a:spcPct val="108000"/>
+              </a:lnSpc>
+              <a:buNone/>
+            </a:pPr>
+            <a:r>
+              <a:rPr lang="en-US" sz="1050" dirty="0">
+                <a:solidFill>
+                  <a:srgbClr val="0F1E2E"/>
+                </a:solidFill>
+                <a:latin typeface="Calibri" pitchFamily="34" charset="0"/>
+                <a:ea typeface="Calibri" pitchFamily="34" charset="-122"/>
+                <a:cs typeface="Calibri" pitchFamily="34" charset="-120"/>
+              </a:rPr>
+              <a:t>The 9 Excel workbooks → receivables, trial balance, BOQ</a:t>
+            </a:r>
+            <a:endParaRPr lang="en-US" sz="1050" dirty="0"/>
+          </a:p>
+        </p:txBody>
+      </p:sp>
+      <p:sp>
+        <p:nvSpPr>
+          <p:cNvPr id="42" name="Shape 40"/>
+          <p:cNvSpPr/>
+          <p:nvPr/>
+        </p:nvSpPr>
+        <p:spPr>
+          <a:xfrm>
+            <a:off x="6126480" y="5129784"/>
+            <a:ext cx="100584" cy="100584"/>
+          </a:xfrm>
+          <a:prstGeom prst="ellipse">
+            <a:avLst/>
+          </a:prstGeom>
+          <a:solidFill>
+            <a:srgbClr val="F2A104"/>
+          </a:solidFill>
+          <a:ln/>
+        </p:spPr>
+      </p:sp>
+      <p:sp>
+        <p:nvSpPr>
+          <p:cNvPr id="43" name="Text 41"/>
+          <p:cNvSpPr/>
+          <p:nvPr/>
+        </p:nvSpPr>
+        <p:spPr>
+          <a:xfrm>
+            <a:off x="6345936" y="5065776"/>
+            <a:ext cx="2240280" cy="713232"/>
+          </a:xfrm>
+          <a:prstGeom prst="rect">
+            <a:avLst/>
+          </a:prstGeom>
+          <a:noFill/>
+          <a:ln/>
+        </p:spPr>
+        <p:txBody>
+          <a:bodyPr wrap="square" lIns="0" tIns="0" rIns="0" bIns="0" rtlCol="0" anchor="ctr"/>
+          <a:lstStyle/>
+          <a:p>
+            <a:pPr indent="0" marL="0">
+              <a:lnSpc>
+                <a:spcPct val="108000"/>
+              </a:lnSpc>
+              <a:buNone/>
+            </a:pPr>
+            <a:r>
+              <a:rPr lang="en-US" sz="1050" dirty="0">
+                <a:solidFill>
+                  <a:srgbClr val="0F1E2E"/>
+                </a:solidFill>
+                <a:latin typeface="Calibri" pitchFamily="34" charset="0"/>
+                <a:ea typeface="Calibri" pitchFamily="34" charset="-122"/>
+                <a:cs typeface="Calibri" pitchFamily="34" charset="-120"/>
+              </a:rPr>
+              <a:t>Independent re-extraction by a second document route — the 155/155 reconciliation</a:t>
+            </a:r>
+            <a:endParaRPr lang="en-US" sz="1050" dirty="0"/>
+          </a:p>
+        </p:txBody>
+      </p:sp>
+      <p:sp>
+        <p:nvSpPr>
+          <p:cNvPr id="44" name="Shape 42"/>
+          <p:cNvSpPr/>
+          <p:nvPr/>
+        </p:nvSpPr>
+        <p:spPr>
+          <a:xfrm>
+            <a:off x="8933688" y="1783080"/>
+            <a:ext cx="2788920" cy="4069080"/>
+          </a:xfrm>
+          <a:prstGeom prst="roundRect">
+            <a:avLst>
+              <a:gd name="adj" fmla="val 2623"/>
+            </a:avLst>
+          </a:prstGeom>
+          <a:solidFill>
+            <a:srgbClr val="F4F6F8"/>
+          </a:solidFill>
+          <a:ln/>
+        </p:spPr>
+      </p:sp>
+      <p:sp>
+        <p:nvSpPr>
+          <p:cNvPr id="45" name="Shape 43"/>
+          <p:cNvSpPr/>
+          <p:nvPr/>
+        </p:nvSpPr>
+        <p:spPr>
+          <a:xfrm>
+            <a:off x="8933688" y="1783080"/>
+            <a:ext cx="2788920" cy="841248"/>
+          </a:xfrm>
+          <a:prstGeom prst="rect">
+            <a:avLst/>
+          </a:prstGeom>
+          <a:solidFill>
+            <a:srgbClr val="0F1E2E"/>
+          </a:solidFill>
+          <a:ln/>
+        </p:spPr>
+      </p:sp>
+      <p:sp>
+        <p:nvSpPr>
+          <p:cNvPr id="46" name="Text 44"/>
+          <p:cNvSpPr/>
+          <p:nvPr/>
+        </p:nvSpPr>
+        <p:spPr>
+          <a:xfrm>
+            <a:off x="9098280" y="1874520"/>
+            <a:ext cx="2468880" cy="292608"/>
+          </a:xfrm>
+          <a:prstGeom prst="rect">
+            <a:avLst/>
+          </a:prstGeom>
+          <a:noFill/>
+          <a:ln/>
+        </p:spPr>
+        <p:txBody>
+          <a:bodyPr wrap="square" lIns="0" tIns="0" rIns="0" bIns="0" rtlCol="0" anchor="ctr"/>
+          <a:lstStyle/>
+          <a:p>
+            <a:pPr indent="0" marL="0">
+              <a:buNone/>
+            </a:pPr>
+            <a:r>
+              <a:rPr lang="en-US" sz="1400" b="1" dirty="0">
                 <a:solidFill>
                   <a:srgbClr val="FFFFFF"/>
                 </a:solidFill>
@@ -7476,22 +8447,22 @@
                 <a:ea typeface="Calibri" pitchFamily="34" charset="-122"/>
                 <a:cs typeface="Calibri" pitchFamily="34" charset="-120"/>
               </a:rPr>
-              <a:t>Treat the scorer as an instrument</a:t>
-            </a:r>
-            <a:endParaRPr lang="en-US" sz="1700" dirty="0"/>
-          </a:p>
-        </p:txBody>
-      </p:sp>
-      <p:sp>
-        <p:nvSpPr>
-          <p:cNvPr id="18" name="Text 16"/>
-          <p:cNvSpPr/>
-          <p:nvPr/>
-        </p:nvSpPr>
-        <p:spPr>
-          <a:xfrm>
-            <a:off x="1188720" y="5413248"/>
-            <a:ext cx="10332720" cy="658368"/>
+              <a:t>[ NAME 2 ]</a:t>
+            </a:r>
+            <a:endParaRPr lang="en-US" sz="1400" dirty="0"/>
+          </a:p>
+        </p:txBody>
+      </p:sp>
+      <p:sp>
+        <p:nvSpPr>
+          <p:cNvPr id="47" name="Text 45"/>
+          <p:cNvSpPr/>
+          <p:nvPr/>
+        </p:nvSpPr>
+        <p:spPr>
+          <a:xfrm>
+            <a:off x="9098280" y="2194560"/>
+            <a:ext cx="2468880" cy="347472"/>
           </a:xfrm>
           <a:prstGeom prst="rect">
             <a:avLst/>
@@ -7505,22 +8476,409 @@
           <a:p>
             <a:pPr indent="0" marL="0">
               <a:lnSpc>
-                <a:spcPct val="115000"/>
+                <a:spcPct val="105000"/>
               </a:lnSpc>
               <a:buNone/>
             </a:pPr>
             <a:r>
-              <a:rPr lang="en-US" sz="1300" dirty="0">
-                <a:solidFill>
-                  <a:srgbClr val="9FB3C2"/>
-                </a:solidFill>
-                <a:latin typeface="Calibri" pitchFamily="34" charset="0"/>
-                <a:ea typeface="Calibri" pitchFamily="34" charset="-122"/>
-                <a:cs typeface="Calibri" pitchFamily="34" charset="-120"/>
-              </a:rPr>
-              <a:t>A three-decimal score over 333 questions resolves a three-hundredth of one question. That is enough to locate a single wrong answer analytically.</a:t>
-            </a:r>
-            <a:endParaRPr lang="en-US" sz="1300" dirty="0"/>
+              <a:rPr lang="en-US" sz="1150" dirty="0">
+                <a:solidFill>
+                  <a:srgbClr val="F2A104"/>
+                </a:solidFill>
+                <a:latin typeface="Calibri" pitchFamily="34" charset="0"/>
+                <a:ea typeface="Calibri" pitchFamily="34" charset="-122"/>
+                <a:cs typeface="Calibri" pitchFamily="34" charset="-120"/>
+              </a:rPr>
+              <a:t>Query layer and verification</a:t>
+            </a:r>
+            <a:endParaRPr lang="en-US" sz="1150" dirty="0"/>
+          </a:p>
+        </p:txBody>
+      </p:sp>
+      <p:sp>
+        <p:nvSpPr>
+          <p:cNvPr id="48" name="Shape 46"/>
+          <p:cNvSpPr/>
+          <p:nvPr/>
+        </p:nvSpPr>
+        <p:spPr>
+          <a:xfrm>
+            <a:off x="9098280" y="2852928"/>
+            <a:ext cx="100584" cy="100584"/>
+          </a:xfrm>
+          <a:prstGeom prst="ellipse">
+            <a:avLst/>
+          </a:prstGeom>
+          <a:solidFill>
+            <a:srgbClr val="F2A104"/>
+          </a:solidFill>
+          <a:ln/>
+        </p:spPr>
+      </p:sp>
+      <p:sp>
+        <p:nvSpPr>
+          <p:cNvPr id="49" name="Text 47"/>
+          <p:cNvSpPr/>
+          <p:nvPr/>
+        </p:nvSpPr>
+        <p:spPr>
+          <a:xfrm>
+            <a:off x="9317736" y="2788920"/>
+            <a:ext cx="2240280" cy="713232"/>
+          </a:xfrm>
+          <a:prstGeom prst="rect">
+            <a:avLst/>
+          </a:prstGeom>
+          <a:noFill/>
+          <a:ln/>
+        </p:spPr>
+        <p:txBody>
+          <a:bodyPr wrap="square" lIns="0" tIns="0" rIns="0" bIns="0" rtlCol="0" anchor="ctr"/>
+          <a:lstStyle/>
+          <a:p>
+            <a:pPr indent="0" marL="0">
+              <a:lnSpc>
+                <a:spcPct val="108000"/>
+              </a:lnSpc>
+              <a:buNone/>
+            </a:pPr>
+            <a:r>
+              <a:rPr lang="en-US" sz="1050" dirty="0">
+                <a:solidFill>
+                  <a:srgbClr val="0F1E2E"/>
+                </a:solidFill>
+                <a:latin typeface="Calibri" pitchFamily="34" charset="0"/>
+                <a:ea typeface="Calibri" pitchFamily="34" charset="-122"/>
+                <a:cs typeface="Calibri" pitchFamily="34" charset="-120"/>
+              </a:rPr>
+              <a:t>Family classifier: question → shape and parameters, 18 families</a:t>
+            </a:r>
+            <a:endParaRPr lang="en-US" sz="1050" dirty="0"/>
+          </a:p>
+        </p:txBody>
+      </p:sp>
+      <p:sp>
+        <p:nvSpPr>
+          <p:cNvPr id="50" name="Shape 48"/>
+          <p:cNvSpPr/>
+          <p:nvPr/>
+        </p:nvSpPr>
+        <p:spPr>
+          <a:xfrm>
+            <a:off x="9098280" y="3611880"/>
+            <a:ext cx="100584" cy="100584"/>
+          </a:xfrm>
+          <a:prstGeom prst="ellipse">
+            <a:avLst/>
+          </a:prstGeom>
+          <a:solidFill>
+            <a:srgbClr val="F2A104"/>
+          </a:solidFill>
+          <a:ln/>
+        </p:spPr>
+      </p:sp>
+      <p:sp>
+        <p:nvSpPr>
+          <p:cNvPr id="51" name="Text 49"/>
+          <p:cNvSpPr/>
+          <p:nvPr/>
+        </p:nvSpPr>
+        <p:spPr>
+          <a:xfrm>
+            <a:off x="9317736" y="3547872"/>
+            <a:ext cx="2240280" cy="713232"/>
+          </a:xfrm>
+          <a:prstGeom prst="rect">
+            <a:avLst/>
+          </a:prstGeom>
+          <a:noFill/>
+          <a:ln/>
+        </p:spPr>
+        <p:txBody>
+          <a:bodyPr wrap="square" lIns="0" tIns="0" rIns="0" bIns="0" rtlCol="0" anchor="ctr"/>
+          <a:lstStyle/>
+          <a:p>
+            <a:pPr indent="0" marL="0">
+              <a:lnSpc>
+                <a:spcPct val="108000"/>
+              </a:lnSpc>
+              <a:buNone/>
+            </a:pPr>
+            <a:r>
+              <a:rPr lang="en-US" sz="1050" dirty="0">
+                <a:solidFill>
+                  <a:srgbClr val="0F1E2E"/>
+                </a:solidFill>
+                <a:latin typeface="Calibri" pitchFamily="34" charset="0"/>
+                <a:ea typeface="Calibri" pitchFamily="34" charset="-122"/>
+                <a:cs typeface="Calibri" pitchFamily="34" charset="-120"/>
+              </a:rPr>
+              <a:t>Executor: the query shapes, where all arithmetic lives</a:t>
+            </a:r>
+            <a:endParaRPr lang="en-US" sz="1050" dirty="0"/>
+          </a:p>
+        </p:txBody>
+      </p:sp>
+      <p:sp>
+        <p:nvSpPr>
+          <p:cNvPr id="52" name="Shape 50"/>
+          <p:cNvSpPr/>
+          <p:nvPr/>
+        </p:nvSpPr>
+        <p:spPr>
+          <a:xfrm>
+            <a:off x="9098280" y="4370832"/>
+            <a:ext cx="100584" cy="100584"/>
+          </a:xfrm>
+          <a:prstGeom prst="ellipse">
+            <a:avLst/>
+          </a:prstGeom>
+          <a:solidFill>
+            <a:srgbClr val="F2A104"/>
+          </a:solidFill>
+          <a:ln/>
+        </p:spPr>
+      </p:sp>
+      <p:sp>
+        <p:nvSpPr>
+          <p:cNvPr id="53" name="Text 51"/>
+          <p:cNvSpPr/>
+          <p:nvPr/>
+        </p:nvSpPr>
+        <p:spPr>
+          <a:xfrm>
+            <a:off x="9317736" y="4306824"/>
+            <a:ext cx="2240280" cy="713232"/>
+          </a:xfrm>
+          <a:prstGeom prst="rect">
+            <a:avLst/>
+          </a:prstGeom>
+          <a:noFill/>
+          <a:ln/>
+        </p:spPr>
+        <p:txBody>
+          <a:bodyPr wrap="square" lIns="0" tIns="0" rIns="0" bIns="0" rtlCol="0" anchor="ctr"/>
+          <a:lstStyle/>
+          <a:p>
+            <a:pPr indent="0" marL="0">
+              <a:lnSpc>
+                <a:spcPct val="108000"/>
+              </a:lnSpc>
+              <a:buNone/>
+            </a:pPr>
+            <a:r>
+              <a:rPr lang="en-US" sz="1050" dirty="0">
+                <a:solidFill>
+                  <a:srgbClr val="0F1E2E"/>
+                </a:solidFill>
+                <a:latin typeface="Calibri" pitchFamily="34" charset="0"/>
+                <a:ea typeface="Calibri" pitchFamily="34" charset="-122"/>
+                <a:cs typeface="Calibri" pitchFamily="34" charset="-120"/>
+              </a:rPr>
+              <a:t>Verification suite, including the checks that need no answer key</a:t>
+            </a:r>
+            <a:endParaRPr lang="en-US" sz="1050" dirty="0"/>
+          </a:p>
+        </p:txBody>
+      </p:sp>
+      <p:sp>
+        <p:nvSpPr>
+          <p:cNvPr id="54" name="Shape 52"/>
+          <p:cNvSpPr/>
+          <p:nvPr/>
+        </p:nvSpPr>
+        <p:spPr>
+          <a:xfrm>
+            <a:off x="9098280" y="5129784"/>
+            <a:ext cx="100584" cy="100584"/>
+          </a:xfrm>
+          <a:prstGeom prst="ellipse">
+            <a:avLst/>
+          </a:prstGeom>
+          <a:solidFill>
+            <a:srgbClr val="F2A104"/>
+          </a:solidFill>
+          <a:ln/>
+        </p:spPr>
+      </p:sp>
+      <p:sp>
+        <p:nvSpPr>
+          <p:cNvPr id="55" name="Text 53"/>
+          <p:cNvSpPr/>
+          <p:nvPr/>
+        </p:nvSpPr>
+        <p:spPr>
+          <a:xfrm>
+            <a:off x="9317736" y="5065776"/>
+            <a:ext cx="2240280" cy="713232"/>
+          </a:xfrm>
+          <a:prstGeom prst="rect">
+            <a:avLst/>
+          </a:prstGeom>
+          <a:noFill/>
+          <a:ln/>
+        </p:spPr>
+        <p:txBody>
+          <a:bodyPr wrap="square" lIns="0" tIns="0" rIns="0" bIns="0" rtlCol="0" anchor="ctr"/>
+          <a:lstStyle/>
+          <a:p>
+            <a:pPr indent="0" marL="0">
+              <a:lnSpc>
+                <a:spcPct val="108000"/>
+              </a:lnSpc>
+              <a:buNone/>
+            </a:pPr>
+            <a:r>
+              <a:rPr lang="en-US" sz="1050" dirty="0">
+                <a:solidFill>
+                  <a:srgbClr val="0F1E2E"/>
+                </a:solidFill>
+                <a:latin typeface="Calibri" pitchFamily="34" charset="0"/>
+                <a:ea typeface="Calibri" pitchFamily="34" charset="-122"/>
+                <a:cs typeface="Calibri" pitchFamily="34" charset="-120"/>
+              </a:rPr>
+              <a:t>Submission strategy and the measurement that located the final error</a:t>
+            </a:r>
+            <a:endParaRPr lang="en-US" sz="1050" dirty="0"/>
+          </a:p>
+        </p:txBody>
+      </p:sp>
+      <p:sp>
+        <p:nvSpPr>
+          <p:cNvPr id="56" name="Shape 54"/>
+          <p:cNvSpPr/>
+          <p:nvPr/>
+        </p:nvSpPr>
+        <p:spPr>
+          <a:xfrm>
+            <a:off x="566928" y="5989320"/>
+            <a:ext cx="11064240" cy="502920"/>
+          </a:xfrm>
+          <a:prstGeom prst="roundRect">
+            <a:avLst>
+              <a:gd name="adj" fmla="val 10909"/>
+            </a:avLst>
+          </a:prstGeom>
+          <a:solidFill>
+            <a:srgbClr val="0F1E2E"/>
+          </a:solidFill>
+          <a:ln/>
+        </p:spPr>
+      </p:sp>
+      <p:sp>
+        <p:nvSpPr>
+          <p:cNvPr id="57" name="Text 55"/>
+          <p:cNvSpPr/>
+          <p:nvPr/>
+        </p:nvSpPr>
+        <p:spPr>
+          <a:xfrm>
+            <a:off x="795528" y="5989320"/>
+            <a:ext cx="3200400" cy="502920"/>
+          </a:xfrm>
+          <a:prstGeom prst="rect">
+            <a:avLst/>
+          </a:prstGeom>
+          <a:noFill/>
+          <a:ln/>
+        </p:spPr>
+        <p:txBody>
+          <a:bodyPr wrap="square" lIns="0" tIns="0" rIns="0" bIns="0" rtlCol="0" anchor="ctr"/>
+          <a:lstStyle/>
+          <a:p>
+            <a:pPr indent="0" marL="0">
+              <a:buNone/>
+            </a:pPr>
+            <a:r>
+              <a:rPr lang="en-US" sz="1150" dirty="0">
+                <a:solidFill>
+                  <a:srgbClr val="B9C7D2"/>
+                </a:solidFill>
+                <a:latin typeface="Calibri" pitchFamily="34" charset="0"/>
+                <a:ea typeface="Calibri" pitchFamily="34" charset="-122"/>
+                <a:cs typeface="Calibri" pitchFamily="34" charset="-120"/>
+              </a:rPr>
+              <a:t>Code, tests and full commit history:</a:t>
+            </a:r>
+            <a:endParaRPr lang="en-US" sz="1150" dirty="0"/>
+          </a:p>
+        </p:txBody>
+      </p:sp>
+      <p:sp>
+        <p:nvSpPr>
+          <p:cNvPr id="58" name="Text 56"/>
+          <p:cNvSpPr/>
+          <p:nvPr/>
+        </p:nvSpPr>
+        <p:spPr>
+          <a:xfrm>
+            <a:off x="3995928" y="5989320"/>
+            <a:ext cx="4754880" cy="502920"/>
+          </a:xfrm>
+          <a:prstGeom prst="rect">
+            <a:avLst/>
+          </a:prstGeom>
+          <a:noFill/>
+          <a:ln/>
+        </p:spPr>
+        <p:txBody>
+          <a:bodyPr wrap="square" lIns="0" tIns="0" rIns="0" bIns="0" rtlCol="0" anchor="ctr"/>
+          <a:lstStyle/>
+          <a:p>
+            <a:pPr indent="0" marL="0">
+              <a:buNone/>
+            </a:pPr>
+            <a:r>
+              <a:rPr lang="en-US" sz="1150" dirty="0">
+                <a:solidFill>
+                  <a:srgbClr val="F2A104"/>
+                </a:solidFill>
+                <a:latin typeface="Courier New" pitchFamily="34" charset="0"/>
+                <a:ea typeface="Courier New" pitchFamily="34" charset="-122"/>
+                <a:cs typeface="Courier New" pitchFamily="34" charset="-120"/>
+              </a:rPr>
+              <a:t>github.com/nilaymastaadmi/jaw2026-trust-reliability</a:t>
+            </a:r>
+            <a:endParaRPr lang="en-US" sz="1150" dirty="0"/>
+          </a:p>
+        </p:txBody>
+      </p:sp>
+      <p:sp>
+        <p:nvSpPr>
+          <p:cNvPr id="59" name="Text 57"/>
+          <p:cNvSpPr/>
+          <p:nvPr/>
+        </p:nvSpPr>
+        <p:spPr>
+          <a:xfrm>
+            <a:off x="8887968" y="5989320"/>
+            <a:ext cx="2514600" cy="502920"/>
+          </a:xfrm>
+          <a:prstGeom prst="rect">
+            <a:avLst/>
+          </a:prstGeom>
+          <a:noFill/>
+          <a:ln/>
+        </p:spPr>
+        <p:txBody>
+          <a:bodyPr wrap="square" lIns="0" tIns="0" rIns="0" bIns="0" rtlCol="0" anchor="ctr"/>
+          <a:lstStyle/>
+          <a:p>
+            <a:pPr algn="r" indent="0" marL="0">
+              <a:buNone/>
+            </a:pPr>
+            <a:r>
+              <a:rPr lang="en-US" sz="1100" dirty="0">
+                <a:solidFill>
+                  <a:srgbClr val="B9C7D2"/>
+                </a:solidFill>
+                <a:latin typeface="Courier New" pitchFamily="34" charset="0"/>
+                <a:ea typeface="Courier New" pitchFamily="34" charset="-122"/>
+                <a:cs typeface="Courier New" pitchFamily="34" charset="-120"/>
+              </a:rPr>
+              <a:t>Scored commit 71ae506</a:t>
+            </a:r>
+            <a:endParaRPr lang="en-US" sz="1100" dirty="0"/>
           </a:p>
         </p:txBody>
       </p:sp>
@@ -7558,6 +8916,637 @@
       </p:grpSpPr>
       <p:sp>
         <p:nvSpPr>
+          <p:cNvPr id="2" name="Text 0"/>
+          <p:cNvSpPr/>
+          <p:nvPr/>
+        </p:nvSpPr>
+        <p:spPr>
+          <a:xfrm>
+            <a:off x="566928" y="685800"/>
+            <a:ext cx="7315200" cy="640080"/>
+          </a:xfrm>
+          <a:prstGeom prst="rect">
+            <a:avLst/>
+          </a:prstGeom>
+          <a:noFill/>
+          <a:ln/>
+        </p:spPr>
+        <p:txBody>
+          <a:bodyPr wrap="square" lIns="0" tIns="0" rIns="0" bIns="0" rtlCol="0" anchor="ctr"/>
+          <a:lstStyle/>
+          <a:p>
+            <a:pPr indent="0" marL="0">
+              <a:buNone/>
+            </a:pPr>
+            <a:r>
+              <a:rPr lang="en-US" sz="3400" b="1" dirty="0">
+                <a:solidFill>
+                  <a:srgbClr val="FFFFFF"/>
+                </a:solidFill>
+                <a:latin typeface="Cambria" pitchFamily="34" charset="0"/>
+                <a:ea typeface="Cambria" pitchFamily="34" charset="-122"/>
+                <a:cs typeface="Cambria" pitchFamily="34" charset="-120"/>
+              </a:rPr>
+              <a:t>What generalises</a:t>
+            </a:r>
+            <a:endParaRPr lang="en-US" sz="3400" dirty="0"/>
+          </a:p>
+        </p:txBody>
+      </p:sp>
+      <p:sp>
+        <p:nvSpPr>
+          <p:cNvPr id="3" name="Shape 1"/>
+          <p:cNvSpPr/>
+          <p:nvPr/>
+        </p:nvSpPr>
+        <p:spPr>
+          <a:xfrm>
+            <a:off x="566928" y="1600200"/>
+            <a:ext cx="402336" cy="402336"/>
+          </a:xfrm>
+          <a:prstGeom prst="ellipse">
+            <a:avLst/>
+          </a:prstGeom>
+          <a:solidFill>
+            <a:srgbClr val="F2A104"/>
+          </a:solidFill>
+          <a:ln/>
+        </p:spPr>
+      </p:sp>
+      <p:sp>
+        <p:nvSpPr>
+          <p:cNvPr id="4" name="Text 2"/>
+          <p:cNvSpPr/>
+          <p:nvPr/>
+        </p:nvSpPr>
+        <p:spPr>
+          <a:xfrm>
+            <a:off x="566928" y="1600200"/>
+            <a:ext cx="402336" cy="402336"/>
+          </a:xfrm>
+          <a:prstGeom prst="rect">
+            <a:avLst/>
+          </a:prstGeom>
+          <a:noFill/>
+          <a:ln/>
+        </p:spPr>
+        <p:txBody>
+          <a:bodyPr wrap="square" lIns="0" tIns="0" rIns="0" bIns="0" rtlCol="0" anchor="ctr"/>
+          <a:lstStyle/>
+          <a:p>
+            <a:pPr algn="ctr" indent="0" marL="0">
+              <a:buNone/>
+            </a:pPr>
+            <a:r>
+              <a:rPr lang="en-US" sz="1500" b="1" dirty="0">
+                <a:solidFill>
+                  <a:srgbClr val="0F1E2E"/>
+                </a:solidFill>
+                <a:latin typeface="Calibri" pitchFamily="34" charset="0"/>
+                <a:ea typeface="Calibri" pitchFamily="34" charset="-122"/>
+                <a:cs typeface="Calibri" pitchFamily="34" charset="-120"/>
+              </a:rPr>
+              <a:t>1</a:t>
+            </a:r>
+            <a:endParaRPr lang="en-US" sz="1500" dirty="0"/>
+          </a:p>
+        </p:txBody>
+      </p:sp>
+      <p:sp>
+        <p:nvSpPr>
+          <p:cNvPr id="5" name="Text 3"/>
+          <p:cNvSpPr/>
+          <p:nvPr/>
+        </p:nvSpPr>
+        <p:spPr>
+          <a:xfrm>
+            <a:off x="1188720" y="1554480"/>
+            <a:ext cx="10332720" cy="329184"/>
+          </a:xfrm>
+          <a:prstGeom prst="rect">
+            <a:avLst/>
+          </a:prstGeom>
+          <a:noFill/>
+          <a:ln/>
+        </p:spPr>
+        <p:txBody>
+          <a:bodyPr wrap="square" lIns="0" tIns="0" rIns="0" bIns="0" rtlCol="0" anchor="ctr"/>
+          <a:lstStyle/>
+          <a:p>
+            <a:pPr indent="0" marL="0">
+              <a:buNone/>
+            </a:pPr>
+            <a:r>
+              <a:rPr lang="en-US" sz="1700" b="1" dirty="0">
+                <a:solidFill>
+                  <a:srgbClr val="FFFFFF"/>
+                </a:solidFill>
+                <a:latin typeface="Calibri" pitchFamily="34" charset="0"/>
+                <a:ea typeface="Calibri" pitchFamily="34" charset="-122"/>
+                <a:cs typeface="Calibri" pitchFamily="34" charset="-120"/>
+              </a:rPr>
+              <a:t>Separate classification from computation</a:t>
+            </a:r>
+            <a:endParaRPr lang="en-US" sz="1700" dirty="0"/>
+          </a:p>
+        </p:txBody>
+      </p:sp>
+      <p:sp>
+        <p:nvSpPr>
+          <p:cNvPr id="6" name="Text 4"/>
+          <p:cNvSpPr/>
+          <p:nvPr/>
+        </p:nvSpPr>
+        <p:spPr>
+          <a:xfrm>
+            <a:off x="1188720" y="1901952"/>
+            <a:ext cx="10332720" cy="658368"/>
+          </a:xfrm>
+          <a:prstGeom prst="rect">
+            <a:avLst/>
+          </a:prstGeom>
+          <a:noFill/>
+          <a:ln/>
+        </p:spPr>
+        <p:txBody>
+          <a:bodyPr wrap="square" lIns="0" tIns="0" rIns="0" bIns="0" rtlCol="0" anchor="ctr"/>
+          <a:lstStyle/>
+          <a:p>
+            <a:pPr indent="0" marL="0">
+              <a:lnSpc>
+                <a:spcPct val="115000"/>
+              </a:lnSpc>
+              <a:buNone/>
+            </a:pPr>
+            <a:r>
+              <a:rPr lang="en-US" sz="1300" dirty="0">
+                <a:solidFill>
+                  <a:srgbClr val="9FB3C2"/>
+                </a:solidFill>
+                <a:latin typeface="Calibri" pitchFamily="34" charset="0"/>
+                <a:ea typeface="Calibri" pitchFamily="34" charset="-122"/>
+                <a:cs typeface="Calibri" pitchFamily="34" charset="-120"/>
+              </a:rPr>
+              <a:t>Let the model decide WHAT to compute and never compute it. Every number stays reproducible, auditable, and exactly as precise as the source document.</a:t>
+            </a:r>
+            <a:endParaRPr lang="en-US" sz="1300" dirty="0"/>
+          </a:p>
+        </p:txBody>
+      </p:sp>
+      <p:sp>
+        <p:nvSpPr>
+          <p:cNvPr id="7" name="Shape 5"/>
+          <p:cNvSpPr/>
+          <p:nvPr/>
+        </p:nvSpPr>
+        <p:spPr>
+          <a:xfrm>
+            <a:off x="566928" y="2770632"/>
+            <a:ext cx="402336" cy="402336"/>
+          </a:xfrm>
+          <a:prstGeom prst="ellipse">
+            <a:avLst/>
+          </a:prstGeom>
+          <a:solidFill>
+            <a:srgbClr val="F2A104"/>
+          </a:solidFill>
+          <a:ln/>
+        </p:spPr>
+      </p:sp>
+      <p:sp>
+        <p:nvSpPr>
+          <p:cNvPr id="8" name="Text 6"/>
+          <p:cNvSpPr/>
+          <p:nvPr/>
+        </p:nvSpPr>
+        <p:spPr>
+          <a:xfrm>
+            <a:off x="566928" y="2770632"/>
+            <a:ext cx="402336" cy="402336"/>
+          </a:xfrm>
+          <a:prstGeom prst="rect">
+            <a:avLst/>
+          </a:prstGeom>
+          <a:noFill/>
+          <a:ln/>
+        </p:spPr>
+        <p:txBody>
+          <a:bodyPr wrap="square" lIns="0" tIns="0" rIns="0" bIns="0" rtlCol="0" anchor="ctr"/>
+          <a:lstStyle/>
+          <a:p>
+            <a:pPr algn="ctr" indent="0" marL="0">
+              <a:buNone/>
+            </a:pPr>
+            <a:r>
+              <a:rPr lang="en-US" sz="1500" b="1" dirty="0">
+                <a:solidFill>
+                  <a:srgbClr val="0F1E2E"/>
+                </a:solidFill>
+                <a:latin typeface="Calibri" pitchFamily="34" charset="0"/>
+                <a:ea typeface="Calibri" pitchFamily="34" charset="-122"/>
+                <a:cs typeface="Calibri" pitchFamily="34" charset="-120"/>
+              </a:rPr>
+              <a:t>2</a:t>
+            </a:r>
+            <a:endParaRPr lang="en-US" sz="1500" dirty="0"/>
+          </a:p>
+        </p:txBody>
+      </p:sp>
+      <p:sp>
+        <p:nvSpPr>
+          <p:cNvPr id="9" name="Text 7"/>
+          <p:cNvSpPr/>
+          <p:nvPr/>
+        </p:nvSpPr>
+        <p:spPr>
+          <a:xfrm>
+            <a:off x="1188720" y="2724912"/>
+            <a:ext cx="10332720" cy="329184"/>
+          </a:xfrm>
+          <a:prstGeom prst="rect">
+            <a:avLst/>
+          </a:prstGeom>
+          <a:noFill/>
+          <a:ln/>
+        </p:spPr>
+        <p:txBody>
+          <a:bodyPr wrap="square" lIns="0" tIns="0" rIns="0" bIns="0" rtlCol="0" anchor="ctr"/>
+          <a:lstStyle/>
+          <a:p>
+            <a:pPr indent="0" marL="0">
+              <a:buNone/>
+            </a:pPr>
+            <a:r>
+              <a:rPr lang="en-US" sz="1700" b="1" dirty="0">
+                <a:solidFill>
+                  <a:srgbClr val="FFFFFF"/>
+                </a:solidFill>
+                <a:latin typeface="Calibri" pitchFamily="34" charset="0"/>
+                <a:ea typeface="Calibri" pitchFamily="34" charset="-122"/>
+                <a:cs typeface="Calibri" pitchFamily="34" charset="-120"/>
+              </a:rPr>
+              <a:t>Corroborate the data layer first</a:t>
+            </a:r>
+            <a:endParaRPr lang="en-US" sz="1700" dirty="0"/>
+          </a:p>
+        </p:txBody>
+      </p:sp>
+      <p:sp>
+        <p:nvSpPr>
+          <p:cNvPr id="10" name="Text 8"/>
+          <p:cNvSpPr/>
+          <p:nvPr/>
+        </p:nvSpPr>
+        <p:spPr>
+          <a:xfrm>
+            <a:off x="1188720" y="3072384"/>
+            <a:ext cx="10332720" cy="658368"/>
+          </a:xfrm>
+          <a:prstGeom prst="rect">
+            <a:avLst/>
+          </a:prstGeom>
+          <a:noFill/>
+          <a:ln/>
+        </p:spPr>
+        <p:txBody>
+          <a:bodyPr wrap="square" lIns="0" tIns="0" rIns="0" bIns="0" rtlCol="0" anchor="ctr"/>
+          <a:lstStyle/>
+          <a:p>
+            <a:pPr indent="0" marL="0">
+              <a:lnSpc>
+                <a:spcPct val="115000"/>
+              </a:lnSpc>
+              <a:buNone/>
+            </a:pPr>
+            <a:r>
+              <a:rPr lang="en-US" sz="1300" dirty="0">
+                <a:solidFill>
+                  <a:srgbClr val="9FB3C2"/>
+                </a:solidFill>
+                <a:latin typeface="Calibri" pitchFamily="34" charset="0"/>
+                <a:ea typeface="Calibri" pitchFamily="34" charset="-122"/>
+                <a:cs typeface="Calibri" pitchFamily="34" charset="-120"/>
+              </a:rPr>
+              <a:t>Extracting the same facts twice by different routes cost a day and bought the deduction that every later error had to be in the query layer.</a:t>
+            </a:r>
+            <a:endParaRPr lang="en-US" sz="1300" dirty="0"/>
+          </a:p>
+        </p:txBody>
+      </p:sp>
+      <p:sp>
+        <p:nvSpPr>
+          <p:cNvPr id="11" name="Shape 9"/>
+          <p:cNvSpPr/>
+          <p:nvPr/>
+        </p:nvSpPr>
+        <p:spPr>
+          <a:xfrm>
+            <a:off x="566928" y="3941064"/>
+            <a:ext cx="402336" cy="402336"/>
+          </a:xfrm>
+          <a:prstGeom prst="ellipse">
+            <a:avLst/>
+          </a:prstGeom>
+          <a:solidFill>
+            <a:srgbClr val="F2A104"/>
+          </a:solidFill>
+          <a:ln/>
+        </p:spPr>
+      </p:sp>
+      <p:sp>
+        <p:nvSpPr>
+          <p:cNvPr id="12" name="Text 10"/>
+          <p:cNvSpPr/>
+          <p:nvPr/>
+        </p:nvSpPr>
+        <p:spPr>
+          <a:xfrm>
+            <a:off x="566928" y="3941064"/>
+            <a:ext cx="402336" cy="402336"/>
+          </a:xfrm>
+          <a:prstGeom prst="rect">
+            <a:avLst/>
+          </a:prstGeom>
+          <a:noFill/>
+          <a:ln/>
+        </p:spPr>
+        <p:txBody>
+          <a:bodyPr wrap="square" lIns="0" tIns="0" rIns="0" bIns="0" rtlCol="0" anchor="ctr"/>
+          <a:lstStyle/>
+          <a:p>
+            <a:pPr algn="ctr" indent="0" marL="0">
+              <a:buNone/>
+            </a:pPr>
+            <a:r>
+              <a:rPr lang="en-US" sz="1500" b="1" dirty="0">
+                <a:solidFill>
+                  <a:srgbClr val="0F1E2E"/>
+                </a:solidFill>
+                <a:latin typeface="Calibri" pitchFamily="34" charset="0"/>
+                <a:ea typeface="Calibri" pitchFamily="34" charset="-122"/>
+                <a:cs typeface="Calibri" pitchFamily="34" charset="-120"/>
+              </a:rPr>
+              <a:t>3</a:t>
+            </a:r>
+            <a:endParaRPr lang="en-US" sz="1500" dirty="0"/>
+          </a:p>
+        </p:txBody>
+      </p:sp>
+      <p:sp>
+        <p:nvSpPr>
+          <p:cNvPr id="13" name="Text 11"/>
+          <p:cNvSpPr/>
+          <p:nvPr/>
+        </p:nvSpPr>
+        <p:spPr>
+          <a:xfrm>
+            <a:off x="1188720" y="3895344"/>
+            <a:ext cx="10332720" cy="329184"/>
+          </a:xfrm>
+          <a:prstGeom prst="rect">
+            <a:avLst/>
+          </a:prstGeom>
+          <a:noFill/>
+          <a:ln/>
+        </p:spPr>
+        <p:txBody>
+          <a:bodyPr wrap="square" lIns="0" tIns="0" rIns="0" bIns="0" rtlCol="0" anchor="ctr"/>
+          <a:lstStyle/>
+          <a:p>
+            <a:pPr indent="0" marL="0">
+              <a:buNone/>
+            </a:pPr>
+            <a:r>
+              <a:rPr lang="en-US" sz="1700" b="1" dirty="0">
+                <a:solidFill>
+                  <a:srgbClr val="FFFFFF"/>
+                </a:solidFill>
+                <a:latin typeface="Calibri" pitchFamily="34" charset="0"/>
+                <a:ea typeface="Calibri" pitchFamily="34" charset="-122"/>
+                <a:cs typeface="Calibri" pitchFamily="34" charset="-120"/>
+              </a:rPr>
+              <a:t>Find invariants that need no answer key</a:t>
+            </a:r>
+            <a:endParaRPr lang="en-US" sz="1700" dirty="0"/>
+          </a:p>
+        </p:txBody>
+      </p:sp>
+      <p:sp>
+        <p:nvSpPr>
+          <p:cNvPr id="14" name="Text 12"/>
+          <p:cNvSpPr/>
+          <p:nvPr/>
+        </p:nvSpPr>
+        <p:spPr>
+          <a:xfrm>
+            <a:off x="1188720" y="4242816"/>
+            <a:ext cx="10332720" cy="658368"/>
+          </a:xfrm>
+          <a:prstGeom prst="rect">
+            <a:avLst/>
+          </a:prstGeom>
+          <a:noFill/>
+          <a:ln/>
+        </p:spPr>
+        <p:txBody>
+          <a:bodyPr wrap="square" lIns="0" tIns="0" rIns="0" bIns="0" rtlCol="0" anchor="ctr"/>
+          <a:lstStyle/>
+          <a:p>
+            <a:pPr indent="0" marL="0">
+              <a:lnSpc>
+                <a:spcPct val="115000"/>
+              </a:lnSpc>
+              <a:buNone/>
+            </a:pPr>
+            <a:r>
+              <a:rPr lang="en-US" sz="1300" dirty="0">
+                <a:solidFill>
+                  <a:srgbClr val="9FB3C2"/>
+                </a:solidFill>
+                <a:latin typeface="Calibri" pitchFamily="34" charset="0"/>
+                <a:ea typeface="Calibri" pitchFamily="34" charset="-122"/>
+                <a:cs typeface="Calibri" pitchFamily="34" charset="-120"/>
+              </a:rPr>
+              <a:t>“A question naming a package is about that package's client” found three silent wrong answers with zero gold data.</a:t>
+            </a:r>
+            <a:endParaRPr lang="en-US" sz="1300" dirty="0"/>
+          </a:p>
+        </p:txBody>
+      </p:sp>
+      <p:sp>
+        <p:nvSpPr>
+          <p:cNvPr id="15" name="Shape 13"/>
+          <p:cNvSpPr/>
+          <p:nvPr/>
+        </p:nvSpPr>
+        <p:spPr>
+          <a:xfrm>
+            <a:off x="566928" y="5111496"/>
+            <a:ext cx="402336" cy="402336"/>
+          </a:xfrm>
+          <a:prstGeom prst="ellipse">
+            <a:avLst/>
+          </a:prstGeom>
+          <a:solidFill>
+            <a:srgbClr val="F2A104"/>
+          </a:solidFill>
+          <a:ln/>
+        </p:spPr>
+      </p:sp>
+      <p:sp>
+        <p:nvSpPr>
+          <p:cNvPr id="16" name="Text 14"/>
+          <p:cNvSpPr/>
+          <p:nvPr/>
+        </p:nvSpPr>
+        <p:spPr>
+          <a:xfrm>
+            <a:off x="566928" y="5111496"/>
+            <a:ext cx="402336" cy="402336"/>
+          </a:xfrm>
+          <a:prstGeom prst="rect">
+            <a:avLst/>
+          </a:prstGeom>
+          <a:noFill/>
+          <a:ln/>
+        </p:spPr>
+        <p:txBody>
+          <a:bodyPr wrap="square" lIns="0" tIns="0" rIns="0" bIns="0" rtlCol="0" anchor="ctr"/>
+          <a:lstStyle/>
+          <a:p>
+            <a:pPr algn="ctr" indent="0" marL="0">
+              <a:buNone/>
+            </a:pPr>
+            <a:r>
+              <a:rPr lang="en-US" sz="1500" b="1" dirty="0">
+                <a:solidFill>
+                  <a:srgbClr val="0F1E2E"/>
+                </a:solidFill>
+                <a:latin typeface="Calibri" pitchFamily="34" charset="0"/>
+                <a:ea typeface="Calibri" pitchFamily="34" charset="-122"/>
+                <a:cs typeface="Calibri" pitchFamily="34" charset="-120"/>
+              </a:rPr>
+              <a:t>4</a:t>
+            </a:r>
+            <a:endParaRPr lang="en-US" sz="1500" dirty="0"/>
+          </a:p>
+        </p:txBody>
+      </p:sp>
+      <p:sp>
+        <p:nvSpPr>
+          <p:cNvPr id="17" name="Text 15"/>
+          <p:cNvSpPr/>
+          <p:nvPr/>
+        </p:nvSpPr>
+        <p:spPr>
+          <a:xfrm>
+            <a:off x="1188720" y="5065776"/>
+            <a:ext cx="10332720" cy="329184"/>
+          </a:xfrm>
+          <a:prstGeom prst="rect">
+            <a:avLst/>
+          </a:prstGeom>
+          <a:noFill/>
+          <a:ln/>
+        </p:spPr>
+        <p:txBody>
+          <a:bodyPr wrap="square" lIns="0" tIns="0" rIns="0" bIns="0" rtlCol="0" anchor="ctr"/>
+          <a:lstStyle/>
+          <a:p>
+            <a:pPr indent="0" marL="0">
+              <a:buNone/>
+            </a:pPr>
+            <a:r>
+              <a:rPr lang="en-US" sz="1700" b="1" dirty="0">
+                <a:solidFill>
+                  <a:srgbClr val="FFFFFF"/>
+                </a:solidFill>
+                <a:latin typeface="Calibri" pitchFamily="34" charset="0"/>
+                <a:ea typeface="Calibri" pitchFamily="34" charset="-122"/>
+                <a:cs typeface="Calibri" pitchFamily="34" charset="-120"/>
+              </a:rPr>
+              <a:t>Treat the scorer as an instrument</a:t>
+            </a:r>
+            <a:endParaRPr lang="en-US" sz="1700" dirty="0"/>
+          </a:p>
+        </p:txBody>
+      </p:sp>
+      <p:sp>
+        <p:nvSpPr>
+          <p:cNvPr id="18" name="Text 16"/>
+          <p:cNvSpPr/>
+          <p:nvPr/>
+        </p:nvSpPr>
+        <p:spPr>
+          <a:xfrm>
+            <a:off x="1188720" y="5413248"/>
+            <a:ext cx="10332720" cy="658368"/>
+          </a:xfrm>
+          <a:prstGeom prst="rect">
+            <a:avLst/>
+          </a:prstGeom>
+          <a:noFill/>
+          <a:ln/>
+        </p:spPr>
+        <p:txBody>
+          <a:bodyPr wrap="square" lIns="0" tIns="0" rIns="0" bIns="0" rtlCol="0" anchor="ctr"/>
+          <a:lstStyle/>
+          <a:p>
+            <a:pPr indent="0" marL="0">
+              <a:lnSpc>
+                <a:spcPct val="115000"/>
+              </a:lnSpc>
+              <a:buNone/>
+            </a:pPr>
+            <a:r>
+              <a:rPr lang="en-US" sz="1300" dirty="0">
+                <a:solidFill>
+                  <a:srgbClr val="9FB3C2"/>
+                </a:solidFill>
+                <a:latin typeface="Calibri" pitchFamily="34" charset="0"/>
+                <a:ea typeface="Calibri" pitchFamily="34" charset="-122"/>
+                <a:cs typeface="Calibri" pitchFamily="34" charset="-120"/>
+              </a:rPr>
+              <a:t>A three-decimal score over 333 questions resolves a three-hundredth of one question. That is enough to locate a single wrong answer analytically.</a:t>
+            </a:r>
+            <a:endParaRPr lang="en-US" sz="1300" dirty="0"/>
+          </a:p>
+        </p:txBody>
+      </p:sp>
+    </p:spTree>
+  </p:cSld>
+  <p:clrMapOvr>
+    <a:masterClrMapping/>
+  </p:clrMapOvr>
+</p:sld>
+</file>
+
+<file path=ppt/slides/slide16.xml><?xml version="1.0" encoding="utf-8"?>
+<p:sld xmlns:a="http://schemas.openxmlformats.org/drawingml/2006/main" xmlns:r="http://schemas.openxmlformats.org/officeDocument/2006/relationships" xmlns:p="http://schemas.openxmlformats.org/presentationml/2006/main">
+  <p:cSld name="Slide 16">
+    <p:bg>
+      <p:bgPr>
+        <a:solidFill>
+          <a:srgbClr val="0F1E2E"/>
+        </a:solidFill>
+      </p:bgPr>
+    </p:bg>
+    <p:spTree>
+      <p:nvGrpSpPr>
+        <p:cNvPr id="1" name=""/>
+        <p:cNvGrpSpPr/>
+        <p:nvPr/>
+      </p:nvGrpSpPr>
+      <p:grpSpPr>
+        <a:xfrm>
+          <a:off x="0" y="0"/>
+          <a:ext cx="0" cy="0"/>
+          <a:chOff x="0" y="0"/>
+          <a:chExt cx="0" cy="0"/>
+        </a:xfrm>
+      </p:grpSpPr>
+      <p:sp>
+        <p:nvSpPr>
           <p:cNvPr id="2" name="Shape 0"/>
           <p:cNvSpPr/>
           <p:nvPr/>
@@ -7769,7 +9758,7 @@
         </p:nvSpPr>
         <p:spPr>
           <a:xfrm>
-            <a:off x="566928" y="5852160"/>
+            <a:off x="566928" y="5715000"/>
             <a:ext cx="6949440" cy="365760"/>
           </a:xfrm>
           <a:prstGeom prst="rect">
@@ -7797,6 +9786,45 @@
               <a:t>Thank you — questions welcome</a:t>
             </a:r>
             <a:endParaRPr lang="en-US" sz="1800" dirty="0"/>
+          </a:p>
+        </p:txBody>
+      </p:sp>
+      <p:sp>
+        <p:nvSpPr>
+          <p:cNvPr id="8" name="Text 6"/>
+          <p:cNvSpPr/>
+          <p:nvPr/>
+        </p:nvSpPr>
+        <p:spPr>
+          <a:xfrm>
+            <a:off x="566928" y="6172200"/>
+            <a:ext cx="8686800" cy="274320"/>
+          </a:xfrm>
+          <a:prstGeom prst="rect">
+            <a:avLst/>
+          </a:prstGeom>
+          <a:noFill/>
+          <a:ln/>
+        </p:spPr>
+        <p:txBody>
+          <a:bodyPr wrap="square" lIns="0" tIns="0" rIns="0" bIns="0" rtlCol="0" anchor="ctr"/>
+          <a:lstStyle/>
+          <a:p>
+            <a:pPr indent="0" marL="0">
+              <a:buNone/>
+            </a:pPr>
+            <a:r>
+              <a:rPr lang="en-US" sz="1050" dirty="0">
+                <a:solidFill>
+                  <a:srgbClr val="2A5C7A"/>
+                </a:solidFill>
+                <a:latin typeface="Courier New" pitchFamily="34" charset="0"/>
+                <a:ea typeface="Courier New" pitchFamily="34" charset="-122"/>
+                <a:cs typeface="Courier New" pitchFamily="34" charset="-120"/>
+              </a:rPr>
+              <a:t>github.com/nilaymastaadmi/jaw2026-trust-reliability   ·   JAW 2026 on GikaGraph</a:t>
+            </a:r>
+            <a:endParaRPr lang="en-US" sz="1050" dirty="0"/>
           </a:p>
         </p:txBody>
       </p:sp>

</xml_diff>

<commit_message>
Our own name is the contractor, and it was resolving to a client
"In how many of the 155 completed works did National Infrastructure Corp.
Ltd. act as a JV Partner rather than Prime contractor" names us, not a
client. Left in the text it scored against the client index on the words
it shares with real client names -- National, Corp, Ltd -- and came back
Suvarna Projects Limited at full confidence, which cut 155 works down to
three.

The contractor's name is masked before client resolution, on every one of
the three retry paths. Masking only the first was no help at all: the
retries run on the raw question by design, and one of them put it
straight back.

Slide 14 carries the team names.

set 3 dev 92.568 -> 92.577, holdout 89.032 -> 89.330. Released 333
byte-identical, samples 21/21, set 1 99.979, set 2 83.192 with listed
100.0, nine suites and both paraphrase banks unchanged.
</commit_message>
<xml_diff>
--- a/presentation/JAW2026-winners-presentation.pptx
+++ b/presentation/JAW2026-winners-presentation.pptx
@@ -8076,7 +8076,7 @@
                 <a:ea typeface="Calibri" pitchFamily="34" charset="-122"/>
                 <a:cs typeface="Calibri" pitchFamily="34" charset="-120"/>
               </a:rPr>
-              <a:t>[ NAME 1 ]</a:t>
+              <a:t>Nilay Toshniwal</a:t>
             </a:r>
             <a:endParaRPr lang="en-US" sz="1400" dirty="0"/>
           </a:p>
@@ -8447,7 +8447,7 @@
                 <a:ea typeface="Calibri" pitchFamily="34" charset="-122"/>
                 <a:cs typeface="Calibri" pitchFamily="34" charset="-120"/>
               </a:rPr>
-              <a:t>[ NAME 2 ]</a:t>
+              <a:t>Shivani Chaudhary</a:t>
             </a:r>
             <a:endParaRPr lang="en-US" sz="1400" dirty="0"/>
           </a:p>

</xml_diff>